<commit_message>
docs(slides): finalize publication attribution and OOD notes
</commit_message>
<xml_diff>
--- a/docs/slides/Molinario_Thesis_Defense_2026.pptx
+++ b/docs/slides/Molinario_Thesis_Defense_2026.pptx
@@ -2,30 +2,30 @@
 <file path=ppt/presentation.xml><?xml version="1.0" encoding="utf-8"?>
 <p:presentation xmlns:p="http://schemas.openxmlformats.org/presentationml/2006/main">
   <p:sldMasterIdLst>
-    <p:sldMasterId xmlns:r="http://schemas.openxmlformats.org/officeDocument/2006/relationships" id="2147483648" r:id="R39bddb2df9784f0f"/>
+    <p:sldMasterId xmlns:r="http://schemas.openxmlformats.org/officeDocument/2006/relationships" id="2147483648" r:id="R0ae1d98ed3504947"/>
   </p:sldMasterIdLst>
   <p:notesMasterIdLst>
-    <p:notesMasterId xmlns:r="http://schemas.openxmlformats.org/officeDocument/2006/relationships" r:id="R680278fb2f594d1d"/>
+    <p:notesMasterId xmlns:r="http://schemas.openxmlformats.org/officeDocument/2006/relationships" r:id="R7346aaaaa5af4429"/>
   </p:notesMasterIdLst>
   <p:sldIdLst>
-    <p:sldId xmlns:r="http://schemas.openxmlformats.org/officeDocument/2006/relationships" id="256" r:id="R090f774546f44547"/>
-    <p:sldId xmlns:r="http://schemas.openxmlformats.org/officeDocument/2006/relationships" id="257" r:id="R9598c231abbb41b6"/>
-    <p:sldId xmlns:r="http://schemas.openxmlformats.org/officeDocument/2006/relationships" id="258" r:id="Ra8fa9f80e48343e0"/>
-    <p:sldId xmlns:r="http://schemas.openxmlformats.org/officeDocument/2006/relationships" id="259" r:id="R1f45a531462446b3"/>
-    <p:sldId xmlns:r="http://schemas.openxmlformats.org/officeDocument/2006/relationships" id="260" r:id="R6629b4153b1549c4"/>
-    <p:sldId xmlns:r="http://schemas.openxmlformats.org/officeDocument/2006/relationships" id="261" r:id="Rb241350067e14881"/>
-    <p:sldId xmlns:r="http://schemas.openxmlformats.org/officeDocument/2006/relationships" id="262" r:id="R4fcb48f642104aaf"/>
-    <p:sldId xmlns:r="http://schemas.openxmlformats.org/officeDocument/2006/relationships" id="263" r:id="R65c1facb61aa4d68"/>
-    <p:sldId xmlns:r="http://schemas.openxmlformats.org/officeDocument/2006/relationships" id="264" r:id="R95df32a5049248ec"/>
-    <p:sldId xmlns:r="http://schemas.openxmlformats.org/officeDocument/2006/relationships" id="265" r:id="R8d34c210fee54903"/>
-    <p:sldId xmlns:r="http://schemas.openxmlformats.org/officeDocument/2006/relationships" id="266" r:id="R91cc894bbc0b4cab"/>
-    <p:sldId xmlns:r="http://schemas.openxmlformats.org/officeDocument/2006/relationships" id="267" r:id="Rc2029d124d574a48"/>
-    <p:sldId xmlns:r="http://schemas.openxmlformats.org/officeDocument/2006/relationships" id="268" r:id="R37a0993ed94e44da"/>
-    <p:sldId xmlns:r="http://schemas.openxmlformats.org/officeDocument/2006/relationships" id="269" r:id="R584d65e8ad6240a3"/>
-    <p:sldId xmlns:r="http://schemas.openxmlformats.org/officeDocument/2006/relationships" id="270" r:id="Ra6c0ec8f5546461f"/>
-    <p:sldId xmlns:r="http://schemas.openxmlformats.org/officeDocument/2006/relationships" id="271" r:id="R77bdd9e08f9b499f"/>
-    <p:sldId xmlns:r="http://schemas.openxmlformats.org/officeDocument/2006/relationships" id="272" r:id="R7a634981d8d14117"/>
-    <p:sldId xmlns:r="http://schemas.openxmlformats.org/officeDocument/2006/relationships" id="273" r:id="R6d99ad735f424309"/>
+    <p:sldId xmlns:r="http://schemas.openxmlformats.org/officeDocument/2006/relationships" id="256" r:id="Raff6f3e6019e48a3"/>
+    <p:sldId xmlns:r="http://schemas.openxmlformats.org/officeDocument/2006/relationships" id="257" r:id="Re2d9f20714bd4b3e"/>
+    <p:sldId xmlns:r="http://schemas.openxmlformats.org/officeDocument/2006/relationships" id="258" r:id="Rfc4496e98525450b"/>
+    <p:sldId xmlns:r="http://schemas.openxmlformats.org/officeDocument/2006/relationships" id="259" r:id="R812eb4f381b549b2"/>
+    <p:sldId xmlns:r="http://schemas.openxmlformats.org/officeDocument/2006/relationships" id="260" r:id="R7b9fb53787684f26"/>
+    <p:sldId xmlns:r="http://schemas.openxmlformats.org/officeDocument/2006/relationships" id="261" r:id="R3b66cf87a4924f97"/>
+    <p:sldId xmlns:r="http://schemas.openxmlformats.org/officeDocument/2006/relationships" id="262" r:id="R91b4ca55478248cd"/>
+    <p:sldId xmlns:r="http://schemas.openxmlformats.org/officeDocument/2006/relationships" id="263" r:id="Rdc570cc1eb5740b0"/>
+    <p:sldId xmlns:r="http://schemas.openxmlformats.org/officeDocument/2006/relationships" id="264" r:id="R6f5565b701894033"/>
+    <p:sldId xmlns:r="http://schemas.openxmlformats.org/officeDocument/2006/relationships" id="265" r:id="Rb1779ad747e943de"/>
+    <p:sldId xmlns:r="http://schemas.openxmlformats.org/officeDocument/2006/relationships" id="266" r:id="Raab344bf0d16441c"/>
+    <p:sldId xmlns:r="http://schemas.openxmlformats.org/officeDocument/2006/relationships" id="267" r:id="R9ab32f8d7278483e"/>
+    <p:sldId xmlns:r="http://schemas.openxmlformats.org/officeDocument/2006/relationships" id="268" r:id="R36eaa5f9214d4d94"/>
+    <p:sldId xmlns:r="http://schemas.openxmlformats.org/officeDocument/2006/relationships" id="269" r:id="Rd0c2b8a1f7314472"/>
+    <p:sldId xmlns:r="http://schemas.openxmlformats.org/officeDocument/2006/relationships" id="270" r:id="Ra10207498d6b4eb3"/>
+    <p:sldId xmlns:r="http://schemas.openxmlformats.org/officeDocument/2006/relationships" id="271" r:id="R103519f77df843b7"/>
+    <p:sldId xmlns:r="http://schemas.openxmlformats.org/officeDocument/2006/relationships" id="272" r:id="R5a621d12267645ef"/>
+    <p:sldId xmlns:r="http://schemas.openxmlformats.org/officeDocument/2006/relationships" id="273" r:id="R77889039708c46f2"/>
   </p:sldIdLst>
   <p:sldSz cx="12192000" cy="6858000"/>
   <p:notesSz cx="6858000" cy="9144000"/>
@@ -569,7 +569,7 @@
           </a:p>
           <a:p xmlns:a="http://schemas.openxmlformats.org/drawingml/2006/main">
             <a:r>
-              <a:t>Every evaluated system assigns at least some OOD images to the weapon-oriented state. The CLIP proxy reaches 83.6 percent, while the commercial configurations range from 23.8 to 52.2 percent. These values are not ordinary false-positive rates because the OOD images have no supervised weapon or non-weapon role in this analysis. They describe closed-set operating behavior and show why clean binary accuracy alone cannot characterize a forensic triage system.</a:t>
+              <a:t>Every evaluated system assigns at least some OOD images to the weapon-oriented state. The CLIP proxy reaches 83.6 percent, while the commercial configurations range from 23.8 to 52.2 percent. For CLIP, the 500 OOD images are evaluated by five fold-specific checkpoints, so 83.6 percent refers to 2,500 responses; each commercial rate uses one normalized decision per image. These values are not ordinary false-positive rates because the OOD images have no supervised weapon or non-weapon role in this analysis. They describe closed-set operating behavior and show why clean binary accuracy alone cannot characterize a forensic triage system.</a:t>
             </a:r>
           </a:p>
           <a:p xmlns:a="http://schemas.openxmlformats.org/drawingml/2006/main">
@@ -595,6 +595,11 @@
           <a:p xmlns:a="http://schemas.openxmlformats.org/drawingml/2006/main">
             <a:r>
               <a:t>- results/figures/chapter_5/tab_forensic_tools_ood_metrics.csv</a:t>
+            </a:r>
+          </a:p>
+          <a:p xmlns:a="http://schemas.openxmlformats.org/drawingml/2006/main">
+            <a:r>
+              <a:t>- docs/LatexThesis/sections/05_implementation.tex — OOD denominator rule</a:t>
             </a:r>
           </a:p>
           <a:p xmlns:a="http://schemas.openxmlformats.org/drawingml/2006/main">
@@ -2134,7 +2139,7 @@
           </a:p>
           <a:p xmlns:a="http://schemas.openxmlformats.org/drawingml/2006/main">
             <a:r>
-              <a:t>- Publication package: DFRWS_27/sections/images/heatmap_blackbox.png</a:t>
+              <a:t>- “FAIRLab: Evaluating the Operational Robustness of AI-Assisted Forensic Image Triage”, black-box heatmap (DFRWS_27/sections/images/heatmap_blackbox.png)</a:t>
             </a:r>
           </a:p>
         </p:txBody>
@@ -2307,7 +2312,7 @@
   </p:cSld>
   <p:clrMap bg1="lt1" tx1="dk1" bg2="lt2" tx2="dk2" accent1="accent1" accent2="accent2" accent3="accent3" accent4="accent4" accent5="accent5" accent6="accent6" hlink="hlink" folHlink="folHlink"/>
   <p:sldLayoutIdLst>
-    <p:sldLayoutId xmlns:r="http://schemas.openxmlformats.org/officeDocument/2006/relationships" id="2147483649" r:id="R8953b284556a4ae0"/>
+    <p:sldLayoutId xmlns:r="http://schemas.openxmlformats.org/officeDocument/2006/relationships" id="2147483649" r:id="Re239be9bea7a4552"/>
   </p:sldLayoutIdLst>
   <p:txStyles>
     <p:titleStyle>
@@ -3404,14 +3409,14 @@
       </p:grpSpPr>
       <p:pic>
         <p:nvPicPr>
-          <p:cNvPr id="6" name=""/>
+          <p:cNvPr id="7" name=""/>
           <p:cNvPicPr>
             <a:picLocks xmlns:a="http://schemas.openxmlformats.org/drawingml/2006/main" noChangeAspect="1"/>
           </p:cNvPicPr>
           <p:nvPr/>
         </p:nvPicPr>
         <p:blipFill>
-          <a:blip xmlns:r="http://schemas.openxmlformats.org/officeDocument/2006/relationships" xmlns:a="http://schemas.openxmlformats.org/drawingml/2006/main" r:embed="R508b5162fa68443a"/>
+          <a:blip xmlns:r="http://schemas.openxmlformats.org/officeDocument/2006/relationships" xmlns:a="http://schemas.openxmlformats.org/drawingml/2006/main" r:embed="R865ddff2ab2749c4"/>
           <a:srcRect xmlns:a="http://schemas.openxmlformats.org/drawingml/2006/main" l="0" t="0" r="0" b="0"/>
           <a:stretch xmlns:a="http://schemas.openxmlformats.org/drawingml/2006/main">
             <a:fillRect l="0" t="0" r="0" b="0"/>
@@ -3462,6 +3467,7 @@
           <a:lstStyle xmlns:a="http://schemas.openxmlformats.org/drawingml/2006/main"/>
           <a:p xmlns:a="http://schemas.openxmlformats.org/drawingml/2006/main">
             <a:pPr algn="l">
+              <a:buNone/>
               <a:defRPr sz="5100" b="1">
                 <a:solidFill>
                   <a:srgbClr val="FFFFFF"/>
@@ -3485,6 +3491,7 @@
           </a:p>
           <a:p xmlns:a="http://schemas.openxmlformats.org/drawingml/2006/main">
             <a:pPr algn="l">
+              <a:buNone/>
               <a:defRPr sz="5100" b="1">
                 <a:solidFill>
                   <a:srgbClr val="FFFFFF"/>
@@ -3508,6 +3515,7 @@
           </a:p>
           <a:p xmlns:a="http://schemas.openxmlformats.org/drawingml/2006/main">
             <a:pPr algn="l">
+              <a:buNone/>
               <a:defRPr sz="5100" b="1">
                 <a:solidFill>
                   <a:srgbClr val="FFFFFF"/>
@@ -3531,6 +3539,7 @@
           </a:p>
           <a:p xmlns:a="http://schemas.openxmlformats.org/drawingml/2006/main">
             <a:pPr algn="l">
+              <a:buNone/>
               <a:defRPr sz="5100" b="1">
                 <a:solidFill>
                   <a:srgbClr val="FFFFFF"/>
@@ -3620,6 +3629,7 @@
           <a:lstStyle xmlns:a="http://schemas.openxmlformats.org/drawingml/2006/main"/>
           <a:p xmlns:a="http://schemas.openxmlformats.org/drawingml/2006/main">
             <a:pPr algn="l">
+              <a:buNone/>
               <a:defRPr sz="1800" b="1">
                 <a:solidFill>
                   <a:srgbClr val="FFFFFF"/>
@@ -3678,6 +3688,7 @@
           <a:lstStyle xmlns:a="http://schemas.openxmlformats.org/drawingml/2006/main"/>
           <a:p xmlns:a="http://schemas.openxmlformats.org/drawingml/2006/main">
             <a:pPr algn="l">
+              <a:buNone/>
               <a:defRPr sz="1500" b="0">
                 <a:solidFill>
                   <a:srgbClr val="DCE4F3"/>
@@ -3701,6 +3712,7 @@
           </a:p>
           <a:p xmlns:a="http://schemas.openxmlformats.org/drawingml/2006/main">
             <a:pPr algn="l">
+              <a:buNone/>
               <a:defRPr sz="1500" b="0">
                 <a:solidFill>
                   <a:srgbClr val="DCE4F3"/>
@@ -3724,6 +3736,7 @@
           </a:p>
           <a:p xmlns:a="http://schemas.openxmlformats.org/drawingml/2006/main">
             <a:pPr algn="l">
+              <a:buNone/>
               <a:defRPr sz="1500" b="0">
                 <a:solidFill>
                   <a:srgbClr val="DCE4F3"/>
@@ -3842,6 +3855,7 @@
           <a:lstStyle xmlns:a="http://schemas.openxmlformats.org/drawingml/2006/main"/>
           <a:p xmlns:a="http://schemas.openxmlformats.org/drawingml/2006/main">
             <a:pPr algn="l">
+              <a:buNone/>
               <a:defRPr sz="3600" b="1">
                 <a:solidFill>
                   <a:srgbClr val="233A70"/>
@@ -3931,6 +3945,7 @@
           <a:lstStyle xmlns:a="http://schemas.openxmlformats.org/drawingml/2006/main"/>
           <a:p xmlns:a="http://schemas.openxmlformats.org/drawingml/2006/main">
             <a:pPr algn="l">
+              <a:buNone/>
               <a:defRPr sz="1050" b="0">
                 <a:solidFill>
                   <a:srgbClr val="5B6577"/>
@@ -3989,6 +4004,7 @@
           <a:lstStyle xmlns:a="http://schemas.openxmlformats.org/drawingml/2006/main"/>
           <a:p xmlns:a="http://schemas.openxmlformats.org/drawingml/2006/main">
             <a:pPr algn="r">
+              <a:buNone/>
               <a:defRPr sz="1050" b="0">
                 <a:solidFill>
                   <a:srgbClr val="5B6577"/>
@@ -4047,6 +4063,7 @@
           <a:lstStyle xmlns:a="http://schemas.openxmlformats.org/drawingml/2006/main"/>
           <a:p xmlns:a="http://schemas.openxmlformats.org/drawingml/2006/main">
             <a:pPr algn="ctr">
+              <a:buNone/>
               <a:defRPr sz="1350" b="0">
                 <a:solidFill>
                   <a:srgbClr val="5B6577"/>
@@ -4072,7 +4089,7 @@
       </p:sp>
       <p:graphicFrame>
         <p:nvGraphicFramePr>
-          <p:cNvPr id="21" name="Chart"/>
+          <p:cNvPr id="23" name="Chart"/>
           <p:cNvGraphicFramePr/>
           <p:nvPr/>
         </p:nvGraphicFramePr>
@@ -4082,7 +4099,7 @@
         </p:xfrm>
         <a:graphic xmlns:a="http://schemas.openxmlformats.org/drawingml/2006/main">
           <a:graphicData uri="http://schemas.openxmlformats.org/drawingml/2006/chart">
-            <c:chart xmlns:r="http://schemas.openxmlformats.org/officeDocument/2006/relationships" xmlns:c="http://schemas.openxmlformats.org/drawingml/2006/chart" r:id="Re6109dba7e294cae"/>
+            <c:chart xmlns:r="http://schemas.openxmlformats.org/officeDocument/2006/relationships" xmlns:c="http://schemas.openxmlformats.org/drawingml/2006/chart" r:id="Rdca9589b37ea43ef"/>
           </a:graphicData>
         </a:graphic>
       </p:graphicFrame>
@@ -4154,6 +4171,7 @@
           <a:lstStyle xmlns:a="http://schemas.openxmlformats.org/drawingml/2006/main"/>
           <a:p xmlns:a="http://schemas.openxmlformats.org/drawingml/2006/main">
             <a:pPr algn="ctr">
+              <a:buNone/>
               <a:defRPr sz="3675" b="1">
                 <a:solidFill>
                   <a:srgbClr val="BE3C37"/>
@@ -4212,6 +4230,7 @@
           <a:lstStyle xmlns:a="http://schemas.openxmlformats.org/drawingml/2006/main"/>
           <a:p xmlns:a="http://schemas.openxmlformats.org/drawingml/2006/main">
             <a:pPr algn="ctr">
+              <a:buNone/>
               <a:defRPr sz="1500" b="1">
                 <a:solidFill>
                   <a:srgbClr val="172033"/>
@@ -4303,6 +4322,7 @@
           <a:lstStyle xmlns:a="http://schemas.openxmlformats.org/drawingml/2006/main"/>
           <a:p xmlns:a="http://schemas.openxmlformats.org/drawingml/2006/main">
             <a:pPr algn="ctr">
+              <a:buNone/>
               <a:defRPr sz="2700" b="1">
                 <a:solidFill>
                   <a:srgbClr val="C89B14"/>
@@ -4361,6 +4381,7 @@
           <a:lstStyle xmlns:a="http://schemas.openxmlformats.org/drawingml/2006/main"/>
           <a:p xmlns:a="http://schemas.openxmlformats.org/drawingml/2006/main">
             <a:pPr algn="ctr">
+              <a:buNone/>
               <a:defRPr sz="1500" b="1">
                 <a:solidFill>
                   <a:srgbClr val="172033"/>
@@ -4419,6 +4440,7 @@
           <a:lstStyle xmlns:a="http://schemas.openxmlformats.org/drawingml/2006/main"/>
           <a:p xmlns:a="http://schemas.openxmlformats.org/drawingml/2006/main">
             <a:pPr algn="ctr">
+              <a:buNone/>
               <a:defRPr sz="1500" b="1">
                 <a:solidFill>
                   <a:srgbClr val="233A70"/>
@@ -4537,6 +4559,7 @@
           <a:lstStyle xmlns:a="http://schemas.openxmlformats.org/drawingml/2006/main"/>
           <a:p xmlns:a="http://schemas.openxmlformats.org/drawingml/2006/main">
             <a:pPr algn="l">
+              <a:buNone/>
               <a:defRPr sz="3600" b="1">
                 <a:solidFill>
                   <a:srgbClr val="233A70"/>
@@ -4626,6 +4649,7 @@
           <a:lstStyle xmlns:a="http://schemas.openxmlformats.org/drawingml/2006/main"/>
           <a:p xmlns:a="http://schemas.openxmlformats.org/drawingml/2006/main">
             <a:pPr algn="l">
+              <a:buNone/>
               <a:defRPr sz="1050" b="0">
                 <a:solidFill>
                   <a:srgbClr val="5B6577"/>
@@ -4684,6 +4708,7 @@
           <a:lstStyle xmlns:a="http://schemas.openxmlformats.org/drawingml/2006/main"/>
           <a:p xmlns:a="http://schemas.openxmlformats.org/drawingml/2006/main">
             <a:pPr algn="r">
+              <a:buNone/>
               <a:defRPr sz="1050" b="0">
                 <a:solidFill>
                   <a:srgbClr val="5B6577"/>
@@ -4709,14 +4734,14 @@
       </p:sp>
       <p:pic>
         <p:nvPicPr>
-          <p:cNvPr id="31" name=""/>
+          <p:cNvPr id="35" name=""/>
           <p:cNvPicPr>
             <a:picLocks xmlns:a="http://schemas.openxmlformats.org/drawingml/2006/main" noChangeAspect="1"/>
           </p:cNvPicPr>
           <p:nvPr/>
         </p:nvPicPr>
         <p:blipFill>
-          <a:blip xmlns:r="http://schemas.openxmlformats.org/officeDocument/2006/relationships" xmlns:a="http://schemas.openxmlformats.org/drawingml/2006/main" r:embed="R42c17bdfdff5403c"/>
+          <a:blip xmlns:r="http://schemas.openxmlformats.org/officeDocument/2006/relationships" xmlns:a="http://schemas.openxmlformats.org/drawingml/2006/main" r:embed="R05e1871d74204f3a"/>
           <a:srcRect xmlns:a="http://schemas.openxmlformats.org/drawingml/2006/main" l="0" t="0" r="0" b="0"/>
           <a:stretch xmlns:a="http://schemas.openxmlformats.org/drawingml/2006/main">
             <a:fillRect l="0" t="0" r="0" b="0"/>
@@ -4769,6 +4794,7 @@
           <a:lstStyle xmlns:a="http://schemas.openxmlformats.org/drawingml/2006/main"/>
           <a:p xmlns:a="http://schemas.openxmlformats.org/drawingml/2006/main">
             <a:pPr algn="ctr">
+              <a:buNone/>
               <a:defRPr sz="1425" b="1">
                 <a:solidFill>
                   <a:srgbClr val="172033"/>
@@ -4827,6 +4853,7 @@
           <a:lstStyle xmlns:a="http://schemas.openxmlformats.org/drawingml/2006/main"/>
           <a:p xmlns:a="http://schemas.openxmlformats.org/drawingml/2006/main">
             <a:pPr algn="ctr">
+              <a:buNone/>
               <a:defRPr sz="1200" b="0">
                 <a:solidFill>
                   <a:srgbClr val="5B6577"/>
@@ -4852,14 +4879,14 @@
       </p:sp>
       <p:pic>
         <p:nvPicPr>
-          <p:cNvPr id="34" name=""/>
+          <p:cNvPr id="38" name=""/>
           <p:cNvPicPr>
             <a:picLocks xmlns:a="http://schemas.openxmlformats.org/drawingml/2006/main" noChangeAspect="1"/>
           </p:cNvPicPr>
           <p:nvPr/>
         </p:nvPicPr>
         <p:blipFill>
-          <a:blip xmlns:r="http://schemas.openxmlformats.org/officeDocument/2006/relationships" xmlns:a="http://schemas.openxmlformats.org/drawingml/2006/main" r:embed="Rd79b65fa49e74fb5"/>
+          <a:blip xmlns:r="http://schemas.openxmlformats.org/officeDocument/2006/relationships" xmlns:a="http://schemas.openxmlformats.org/drawingml/2006/main" r:embed="R1db6aced1e6a4880"/>
           <a:srcRect xmlns:a="http://schemas.openxmlformats.org/drawingml/2006/main" l="0" t="0" r="0" b="0"/>
           <a:stretch xmlns:a="http://schemas.openxmlformats.org/drawingml/2006/main">
             <a:fillRect l="0" t="0" r="0" b="0"/>
@@ -4912,6 +4939,7 @@
           <a:lstStyle xmlns:a="http://schemas.openxmlformats.org/drawingml/2006/main"/>
           <a:p xmlns:a="http://schemas.openxmlformats.org/drawingml/2006/main">
             <a:pPr algn="ctr">
+              <a:buNone/>
               <a:defRPr sz="1425" b="1">
                 <a:solidFill>
                   <a:srgbClr val="172033"/>
@@ -4970,6 +4998,7 @@
           <a:lstStyle xmlns:a="http://schemas.openxmlformats.org/drawingml/2006/main"/>
           <a:p xmlns:a="http://schemas.openxmlformats.org/drawingml/2006/main">
             <a:pPr algn="ctr">
+              <a:buNone/>
               <a:defRPr sz="1200" b="0">
                 <a:solidFill>
                   <a:srgbClr val="5B6577"/>
@@ -4995,14 +5024,14 @@
       </p:sp>
       <p:pic>
         <p:nvPicPr>
-          <p:cNvPr id="37" name=""/>
+          <p:cNvPr id="41" name=""/>
           <p:cNvPicPr>
             <a:picLocks xmlns:a="http://schemas.openxmlformats.org/drawingml/2006/main" noChangeAspect="1"/>
           </p:cNvPicPr>
           <p:nvPr/>
         </p:nvPicPr>
         <p:blipFill>
-          <a:blip xmlns:r="http://schemas.openxmlformats.org/officeDocument/2006/relationships" xmlns:a="http://schemas.openxmlformats.org/drawingml/2006/main" r:embed="R7eec9a3aa82b4a32"/>
+          <a:blip xmlns:r="http://schemas.openxmlformats.org/officeDocument/2006/relationships" xmlns:a="http://schemas.openxmlformats.org/drawingml/2006/main" r:embed="R97850788fe824f62"/>
           <a:srcRect xmlns:a="http://schemas.openxmlformats.org/drawingml/2006/main" l="0" t="0" r="0" b="0"/>
           <a:stretch xmlns:a="http://schemas.openxmlformats.org/drawingml/2006/main">
             <a:fillRect l="0" t="0" r="0" b="0"/>
@@ -5055,6 +5084,7 @@
           <a:lstStyle xmlns:a="http://schemas.openxmlformats.org/drawingml/2006/main"/>
           <a:p xmlns:a="http://schemas.openxmlformats.org/drawingml/2006/main">
             <a:pPr algn="ctr">
+              <a:buNone/>
               <a:defRPr sz="1425" b="1">
                 <a:solidFill>
                   <a:srgbClr val="172033"/>
@@ -5113,6 +5143,7 @@
           <a:lstStyle xmlns:a="http://schemas.openxmlformats.org/drawingml/2006/main"/>
           <a:p xmlns:a="http://schemas.openxmlformats.org/drawingml/2006/main">
             <a:pPr algn="ctr">
+              <a:buNone/>
               <a:defRPr sz="1200" b="0">
                 <a:solidFill>
                   <a:srgbClr val="5B6577"/>
@@ -5204,6 +5235,7 @@
           <a:lstStyle xmlns:a="http://schemas.openxmlformats.org/drawingml/2006/main"/>
           <a:p xmlns:a="http://schemas.openxmlformats.org/drawingml/2006/main">
             <a:pPr algn="ctr">
+              <a:buNone/>
               <a:defRPr sz="1275" b="1">
                 <a:solidFill>
                   <a:srgbClr val="14B978"/>
@@ -5262,6 +5294,7 @@
           <a:lstStyle xmlns:a="http://schemas.openxmlformats.org/drawingml/2006/main"/>
           <a:p xmlns:a="http://schemas.openxmlformats.org/drawingml/2006/main">
             <a:pPr algn="ctr">
+              <a:buNone/>
               <a:defRPr sz="1200" b="1">
                 <a:solidFill>
                   <a:srgbClr val="DCE4F3"/>
@@ -5320,6 +5353,7 @@
           <a:lstStyle xmlns:a="http://schemas.openxmlformats.org/drawingml/2006/main"/>
           <a:p xmlns:a="http://schemas.openxmlformats.org/drawingml/2006/main">
             <a:pPr algn="ctr">
+              <a:buNone/>
               <a:defRPr sz="1650" b="1">
                 <a:solidFill>
                   <a:srgbClr val="FFFFFF"/>
@@ -5378,6 +5412,7 @@
           <a:lstStyle xmlns:a="http://schemas.openxmlformats.org/drawingml/2006/main"/>
           <a:p xmlns:a="http://schemas.openxmlformats.org/drawingml/2006/main">
             <a:pPr algn="ctr">
+              <a:buNone/>
               <a:defRPr sz="1200" b="1">
                 <a:solidFill>
                   <a:srgbClr val="DCE4F3"/>
@@ -5436,6 +5471,7 @@
           <a:lstStyle xmlns:a="http://schemas.openxmlformats.org/drawingml/2006/main"/>
           <a:p xmlns:a="http://schemas.openxmlformats.org/drawingml/2006/main">
             <a:pPr algn="ctr">
+              <a:buNone/>
               <a:defRPr sz="1650" b="1">
                 <a:solidFill>
                   <a:srgbClr val="FFFFFF"/>
@@ -5525,6 +5561,7 @@
           <a:lstStyle xmlns:a="http://schemas.openxmlformats.org/drawingml/2006/main"/>
           <a:p xmlns:a="http://schemas.openxmlformats.org/drawingml/2006/main">
             <a:pPr algn="ctr">
+              <a:buNone/>
               <a:defRPr sz="1200" b="1">
                 <a:solidFill>
                   <a:srgbClr val="14B978"/>
@@ -5583,6 +5620,7 @@
           <a:lstStyle xmlns:a="http://schemas.openxmlformats.org/drawingml/2006/main"/>
           <a:p xmlns:a="http://schemas.openxmlformats.org/drawingml/2006/main">
             <a:pPr algn="ctr">
+              <a:buNone/>
               <a:defRPr sz="3375" b="1">
                 <a:solidFill>
                   <a:srgbClr val="FFFFFF"/>
@@ -5674,6 +5712,7 @@
           <a:lstStyle xmlns:a="http://schemas.openxmlformats.org/drawingml/2006/main"/>
           <a:p xmlns:a="http://schemas.openxmlformats.org/drawingml/2006/main">
             <a:pPr algn="ctr">
+              <a:buNone/>
               <a:defRPr sz="1650" b="1">
                 <a:solidFill>
                   <a:srgbClr val="087A50"/>
@@ -5697,6 +5736,7 @@
           </a:p>
           <a:p xmlns:a="http://schemas.openxmlformats.org/drawingml/2006/main">
             <a:pPr algn="ctr">
+              <a:buNone/>
               <a:defRPr sz="1650" b="1">
                 <a:solidFill>
                   <a:srgbClr val="087A50"/>
@@ -5815,6 +5855,7 @@
           <a:lstStyle xmlns:a="http://schemas.openxmlformats.org/drawingml/2006/main"/>
           <a:p xmlns:a="http://schemas.openxmlformats.org/drawingml/2006/main">
             <a:pPr algn="l">
+              <a:buNone/>
               <a:defRPr sz="3600" b="1">
                 <a:solidFill>
                   <a:srgbClr val="233A70"/>
@@ -5904,6 +5945,7 @@
           <a:lstStyle xmlns:a="http://schemas.openxmlformats.org/drawingml/2006/main"/>
           <a:p xmlns:a="http://schemas.openxmlformats.org/drawingml/2006/main">
             <a:pPr algn="l">
+              <a:buNone/>
               <a:defRPr sz="1050" b="0">
                 <a:solidFill>
                   <a:srgbClr val="5B6577"/>
@@ -5962,6 +6004,7 @@
           <a:lstStyle xmlns:a="http://schemas.openxmlformats.org/drawingml/2006/main"/>
           <a:p xmlns:a="http://schemas.openxmlformats.org/drawingml/2006/main">
             <a:pPr algn="r">
+              <a:buNone/>
               <a:defRPr sz="1050" b="0">
                 <a:solidFill>
                   <a:srgbClr val="5B6577"/>
@@ -6051,6 +6094,7 @@
           <a:lstStyle xmlns:a="http://schemas.openxmlformats.org/drawingml/2006/main"/>
           <a:p xmlns:a="http://schemas.openxmlformats.org/drawingml/2006/main">
             <a:pPr algn="ctr">
+              <a:buNone/>
               <a:defRPr sz="1350" b="1">
                 <a:solidFill>
                   <a:srgbClr val="233A70"/>
@@ -6144,6 +6188,7 @@
           <a:lstStyle xmlns:a="http://schemas.openxmlformats.org/drawingml/2006/main"/>
           <a:p xmlns:a="http://schemas.openxmlformats.org/drawingml/2006/main">
             <a:pPr algn="ctr">
+              <a:buNone/>
               <a:defRPr sz="1800" b="1">
                 <a:solidFill>
                   <a:srgbClr val="233A70"/>
@@ -6202,6 +6247,7 @@
           <a:lstStyle xmlns:a="http://schemas.openxmlformats.org/drawingml/2006/main"/>
           <a:p xmlns:a="http://schemas.openxmlformats.org/drawingml/2006/main">
             <a:pPr algn="ctr">
+              <a:buNone/>
               <a:defRPr sz="1425" b="0">
                 <a:solidFill>
                   <a:srgbClr val="5B6577"/>
@@ -6225,6 +6271,7 @@
           </a:p>
           <a:p xmlns:a="http://schemas.openxmlformats.org/drawingml/2006/main">
             <a:pPr algn="ctr">
+              <a:buNone/>
               <a:defRPr sz="1425" b="0">
                 <a:solidFill>
                   <a:srgbClr val="5B6577"/>
@@ -6283,6 +6330,7 @@
           <a:lstStyle xmlns:a="http://schemas.openxmlformats.org/drawingml/2006/main"/>
           <a:p xmlns:a="http://schemas.openxmlformats.org/drawingml/2006/main">
             <a:pPr algn="ctr">
+              <a:buNone/>
               <a:defRPr sz="1350" b="1">
                 <a:solidFill>
                   <a:srgbClr val="233A70"/>
@@ -6376,6 +6424,7 @@
           <a:lstStyle xmlns:a="http://schemas.openxmlformats.org/drawingml/2006/main"/>
           <a:p xmlns:a="http://schemas.openxmlformats.org/drawingml/2006/main">
             <a:pPr algn="ctr">
+              <a:buNone/>
               <a:defRPr sz="1800" b="1">
                 <a:solidFill>
                   <a:srgbClr val="233A70"/>
@@ -6434,6 +6483,7 @@
           <a:lstStyle xmlns:a="http://schemas.openxmlformats.org/drawingml/2006/main"/>
           <a:p xmlns:a="http://schemas.openxmlformats.org/drawingml/2006/main">
             <a:pPr algn="ctr">
+              <a:buNone/>
               <a:defRPr sz="1425" b="0">
                 <a:solidFill>
                   <a:srgbClr val="5B6577"/>
@@ -6457,6 +6507,7 @@
           </a:p>
           <a:p xmlns:a="http://schemas.openxmlformats.org/drawingml/2006/main">
             <a:pPr algn="ctr">
+              <a:buNone/>
               <a:defRPr sz="1425" b="0">
                 <a:solidFill>
                   <a:srgbClr val="5B6577"/>
@@ -6515,6 +6566,7 @@
           <a:lstStyle xmlns:a="http://schemas.openxmlformats.org/drawingml/2006/main"/>
           <a:p xmlns:a="http://schemas.openxmlformats.org/drawingml/2006/main">
             <a:pPr algn="ctr">
+              <a:buNone/>
               <a:defRPr sz="1350" b="1">
                 <a:solidFill>
                   <a:srgbClr val="087A50"/>
@@ -6608,6 +6660,7 @@
           <a:lstStyle xmlns:a="http://schemas.openxmlformats.org/drawingml/2006/main"/>
           <a:p xmlns:a="http://schemas.openxmlformats.org/drawingml/2006/main">
             <a:pPr algn="ctr">
+              <a:buNone/>
               <a:defRPr sz="1800" b="1">
                 <a:solidFill>
                   <a:srgbClr val="087A50"/>
@@ -6666,6 +6719,7 @@
           <a:lstStyle xmlns:a="http://schemas.openxmlformats.org/drawingml/2006/main"/>
           <a:p xmlns:a="http://schemas.openxmlformats.org/drawingml/2006/main">
             <a:pPr algn="ctr">
+              <a:buNone/>
               <a:defRPr sz="1425" b="0">
                 <a:solidFill>
                   <a:srgbClr val="5B6577"/>
@@ -6689,6 +6743,7 @@
           </a:p>
           <a:p xmlns:a="http://schemas.openxmlformats.org/drawingml/2006/main">
             <a:pPr algn="ctr">
+              <a:buNone/>
               <a:defRPr sz="1425" b="0">
                 <a:solidFill>
                   <a:srgbClr val="5B6577"/>
@@ -6747,6 +6802,7 @@
           <a:lstStyle xmlns:a="http://schemas.openxmlformats.org/drawingml/2006/main"/>
           <a:p xmlns:a="http://schemas.openxmlformats.org/drawingml/2006/main">
             <a:pPr algn="ctr">
+              <a:buNone/>
               <a:defRPr sz="1350" b="1">
                 <a:solidFill>
                   <a:srgbClr val="233A70"/>
@@ -6840,6 +6896,7 @@
           <a:lstStyle xmlns:a="http://schemas.openxmlformats.org/drawingml/2006/main"/>
           <a:p xmlns:a="http://schemas.openxmlformats.org/drawingml/2006/main">
             <a:pPr algn="ctr">
+              <a:buNone/>
               <a:defRPr sz="1800" b="1">
                 <a:solidFill>
                   <a:srgbClr val="233A70"/>
@@ -6898,6 +6955,7 @@
           <a:lstStyle xmlns:a="http://schemas.openxmlformats.org/drawingml/2006/main"/>
           <a:p xmlns:a="http://schemas.openxmlformats.org/drawingml/2006/main">
             <a:pPr algn="ctr">
+              <a:buNone/>
               <a:defRPr sz="1425" b="0">
                 <a:solidFill>
                   <a:srgbClr val="5B6577"/>
@@ -6921,6 +6979,7 @@
           </a:p>
           <a:p xmlns:a="http://schemas.openxmlformats.org/drawingml/2006/main">
             <a:pPr algn="ctr">
+              <a:buNone/>
               <a:defRPr sz="1425" b="0">
                 <a:solidFill>
                   <a:srgbClr val="5B6577"/>
@@ -6979,6 +7038,7 @@
           <a:lstStyle xmlns:a="http://schemas.openxmlformats.org/drawingml/2006/main"/>
           <a:p xmlns:a="http://schemas.openxmlformats.org/drawingml/2006/main">
             <a:pPr algn="ctr">
+              <a:buNone/>
               <a:defRPr sz="1350" b="1">
                 <a:solidFill>
                   <a:srgbClr val="233A70"/>
@@ -7037,6 +7097,7 @@
           <a:lstStyle xmlns:a="http://schemas.openxmlformats.org/drawingml/2006/main"/>
           <a:p xmlns:a="http://schemas.openxmlformats.org/drawingml/2006/main">
             <a:pPr algn="ctr">
+              <a:buNone/>
               <a:defRPr sz="1575" b="1">
                 <a:solidFill>
                   <a:srgbClr val="172033"/>
@@ -7126,6 +7187,7 @@
           <a:lstStyle xmlns:a="http://schemas.openxmlformats.org/drawingml/2006/main"/>
           <a:p xmlns:a="http://schemas.openxmlformats.org/drawingml/2006/main">
             <a:pPr algn="ctr">
+              <a:buNone/>
               <a:defRPr sz="1575" b="1">
                 <a:solidFill>
                   <a:srgbClr val="172033"/>
@@ -7215,6 +7277,7 @@
           <a:lstStyle xmlns:a="http://schemas.openxmlformats.org/drawingml/2006/main"/>
           <a:p xmlns:a="http://schemas.openxmlformats.org/drawingml/2006/main">
             <a:pPr algn="ctr">
+              <a:buNone/>
               <a:defRPr sz="1575" b="1">
                 <a:solidFill>
                   <a:srgbClr val="172033"/>
@@ -7304,6 +7367,7 @@
           <a:lstStyle xmlns:a="http://schemas.openxmlformats.org/drawingml/2006/main"/>
           <a:p xmlns:a="http://schemas.openxmlformats.org/drawingml/2006/main">
             <a:pPr algn="ctr">
+              <a:buNone/>
               <a:defRPr sz="1575" b="1">
                 <a:solidFill>
                   <a:srgbClr val="172033"/>
@@ -7395,6 +7459,7 @@
           <a:lstStyle xmlns:a="http://schemas.openxmlformats.org/drawingml/2006/main"/>
           <a:p xmlns:a="http://schemas.openxmlformats.org/drawingml/2006/main">
             <a:pPr algn="ctr">
+              <a:buNone/>
               <a:defRPr sz="2025" b="1">
                 <a:solidFill>
                   <a:srgbClr val="FFFFFF"/>
@@ -7449,14 +7514,14 @@
       </p:grpSpPr>
       <p:pic>
         <p:nvPicPr>
-          <p:cNvPr id="14" name=""/>
+          <p:cNvPr id="15" name=""/>
           <p:cNvPicPr>
             <a:picLocks xmlns:a="http://schemas.openxmlformats.org/drawingml/2006/main" noChangeAspect="1"/>
           </p:cNvPicPr>
           <p:nvPr/>
         </p:nvPicPr>
         <p:blipFill>
-          <a:blip xmlns:r="http://schemas.openxmlformats.org/officeDocument/2006/relationships" xmlns:a="http://schemas.openxmlformats.org/drawingml/2006/main" r:embed="Rc5e4701042fc43ce"/>
+          <a:blip xmlns:r="http://schemas.openxmlformats.org/officeDocument/2006/relationships" xmlns:a="http://schemas.openxmlformats.org/drawingml/2006/main" r:embed="Re5a839c749dd48b7"/>
           <a:stretch xmlns:a="http://schemas.openxmlformats.org/drawingml/2006/main"/>
         </p:blipFill>
         <p:spPr>
@@ -7504,6 +7569,7 @@
           <a:lstStyle xmlns:a="http://schemas.openxmlformats.org/drawingml/2006/main"/>
           <a:p xmlns:a="http://schemas.openxmlformats.org/drawingml/2006/main">
             <a:pPr algn="l">
+              <a:buNone/>
               <a:defRPr sz="4200" b="1">
                 <a:solidFill>
                   <a:srgbClr val="FFFFFF"/>
@@ -7527,6 +7593,7 @@
           </a:p>
           <a:p xmlns:a="http://schemas.openxmlformats.org/drawingml/2006/main">
             <a:pPr algn="l">
+              <a:buNone/>
               <a:defRPr sz="4200" b="1">
                 <a:solidFill>
                   <a:srgbClr val="FFFFFF"/>
@@ -7616,6 +7683,7 @@
           <a:lstStyle xmlns:a="http://schemas.openxmlformats.org/drawingml/2006/main"/>
           <a:p xmlns:a="http://schemas.openxmlformats.org/drawingml/2006/main">
             <a:pPr algn="l">
+              <a:buNone/>
               <a:defRPr sz="1575" b="1">
                 <a:solidFill>
                   <a:srgbClr val="14B978"/>
@@ -7674,6 +7742,7 @@
           <a:lstStyle xmlns:a="http://schemas.openxmlformats.org/drawingml/2006/main"/>
           <a:p xmlns:a="http://schemas.openxmlformats.org/drawingml/2006/main">
             <a:pPr algn="l">
+              <a:buNone/>
               <a:defRPr sz="1875" b="1">
                 <a:solidFill>
                   <a:srgbClr val="FFFFFF"/>
@@ -7763,6 +7832,7 @@
           <a:lstStyle xmlns:a="http://schemas.openxmlformats.org/drawingml/2006/main"/>
           <a:p xmlns:a="http://schemas.openxmlformats.org/drawingml/2006/main">
             <a:pPr algn="l">
+              <a:buNone/>
               <a:defRPr sz="1575" b="1">
                 <a:solidFill>
                   <a:srgbClr val="14B978"/>
@@ -7821,6 +7891,7 @@
           <a:lstStyle xmlns:a="http://schemas.openxmlformats.org/drawingml/2006/main"/>
           <a:p xmlns:a="http://schemas.openxmlformats.org/drawingml/2006/main">
             <a:pPr algn="l">
+              <a:buNone/>
               <a:defRPr sz="1875" b="1">
                 <a:solidFill>
                   <a:srgbClr val="FFFFFF"/>
@@ -7910,6 +7981,7 @@
           <a:lstStyle xmlns:a="http://schemas.openxmlformats.org/drawingml/2006/main"/>
           <a:p xmlns:a="http://schemas.openxmlformats.org/drawingml/2006/main">
             <a:pPr algn="l">
+              <a:buNone/>
               <a:defRPr sz="1575" b="1">
                 <a:solidFill>
                   <a:srgbClr val="14B978"/>
@@ -7968,6 +8040,7 @@
           <a:lstStyle xmlns:a="http://schemas.openxmlformats.org/drawingml/2006/main"/>
           <a:p xmlns:a="http://schemas.openxmlformats.org/drawingml/2006/main">
             <a:pPr algn="l">
+              <a:buNone/>
               <a:defRPr sz="1875" b="1">
                 <a:solidFill>
                   <a:srgbClr val="FFFFFF"/>
@@ -8026,6 +8099,7 @@
           <a:lstStyle xmlns:a="http://schemas.openxmlformats.org/drawingml/2006/main"/>
           <a:p xmlns:a="http://schemas.openxmlformats.org/drawingml/2006/main">
             <a:pPr algn="l">
+              <a:buNone/>
               <a:defRPr sz="2025" b="1">
                 <a:solidFill>
                   <a:srgbClr val="DCE4F3"/>
@@ -8084,6 +8158,7 @@
           <a:lstStyle xmlns:a="http://schemas.openxmlformats.org/drawingml/2006/main"/>
           <a:p xmlns:a="http://schemas.openxmlformats.org/drawingml/2006/main">
             <a:pPr algn="r">
+              <a:buNone/>
               <a:defRPr sz="1200" b="0">
                 <a:solidFill>
                   <a:srgbClr val="9FB0D3"/>
@@ -8202,6 +8277,7 @@
           <a:lstStyle xmlns:a="http://schemas.openxmlformats.org/drawingml/2006/main"/>
           <a:p xmlns:a="http://schemas.openxmlformats.org/drawingml/2006/main">
             <a:pPr algn="l">
+              <a:buNone/>
               <a:defRPr sz="3600" b="1">
                 <a:solidFill>
                   <a:srgbClr val="233A70"/>
@@ -8291,6 +8367,7 @@
           <a:lstStyle xmlns:a="http://schemas.openxmlformats.org/drawingml/2006/main"/>
           <a:p xmlns:a="http://schemas.openxmlformats.org/drawingml/2006/main">
             <a:pPr algn="l">
+              <a:buNone/>
               <a:defRPr sz="1050" b="0">
                 <a:solidFill>
                   <a:srgbClr val="5B6577"/>
@@ -8349,6 +8426,7 @@
           <a:lstStyle xmlns:a="http://schemas.openxmlformats.org/drawingml/2006/main"/>
           <a:p xmlns:a="http://schemas.openxmlformats.org/drawingml/2006/main">
             <a:pPr algn="r">
+              <a:buNone/>
               <a:defRPr sz="1050" b="0">
                 <a:solidFill>
                   <a:srgbClr val="5B6577"/>
@@ -8407,6 +8485,7 @@
           <a:lstStyle xmlns:a="http://schemas.openxmlformats.org/drawingml/2006/main"/>
           <a:p xmlns:a="http://schemas.openxmlformats.org/drawingml/2006/main">
             <a:pPr algn="ctr">
+              <a:buNone/>
               <a:defRPr sz="2100" b="1">
                 <a:solidFill>
                   <a:srgbClr val="233A70"/>
@@ -8465,6 +8544,7 @@
           <a:lstStyle xmlns:a="http://schemas.openxmlformats.org/drawingml/2006/main"/>
           <a:p xmlns:a="http://schemas.openxmlformats.org/drawingml/2006/main">
             <a:pPr algn="l">
+              <a:buNone/>
               <a:defRPr sz="1650" b="0">
                 <a:solidFill>
                   <a:srgbClr val="172033"/>
@@ -8554,6 +8634,7 @@
           <a:lstStyle xmlns:a="http://schemas.openxmlformats.org/drawingml/2006/main"/>
           <a:p xmlns:a="http://schemas.openxmlformats.org/drawingml/2006/main">
             <a:pPr algn="ctr">
+              <a:buNone/>
               <a:defRPr sz="2100" b="1">
                 <a:solidFill>
                   <a:srgbClr val="233A70"/>
@@ -8612,6 +8693,7 @@
           <a:lstStyle xmlns:a="http://schemas.openxmlformats.org/drawingml/2006/main"/>
           <a:p xmlns:a="http://schemas.openxmlformats.org/drawingml/2006/main">
             <a:pPr algn="l">
+              <a:buNone/>
               <a:defRPr sz="1650" b="0">
                 <a:solidFill>
                   <a:srgbClr val="172033"/>
@@ -8701,6 +8783,7 @@
           <a:lstStyle xmlns:a="http://schemas.openxmlformats.org/drawingml/2006/main"/>
           <a:p xmlns:a="http://schemas.openxmlformats.org/drawingml/2006/main">
             <a:pPr algn="ctr">
+              <a:buNone/>
               <a:defRPr sz="2100" b="1">
                 <a:solidFill>
                   <a:srgbClr val="233A70"/>
@@ -8759,6 +8842,7 @@
           <a:lstStyle xmlns:a="http://schemas.openxmlformats.org/drawingml/2006/main"/>
           <a:p xmlns:a="http://schemas.openxmlformats.org/drawingml/2006/main">
             <a:pPr algn="l">
+              <a:buNone/>
               <a:defRPr sz="1650" b="0">
                 <a:solidFill>
                   <a:srgbClr val="172033"/>
@@ -8848,6 +8932,7 @@
           <a:lstStyle xmlns:a="http://schemas.openxmlformats.org/drawingml/2006/main"/>
           <a:p xmlns:a="http://schemas.openxmlformats.org/drawingml/2006/main">
             <a:pPr algn="ctr">
+              <a:buNone/>
               <a:defRPr sz="2100" b="1">
                 <a:solidFill>
                   <a:srgbClr val="233A70"/>
@@ -8906,6 +8991,7 @@
           <a:lstStyle xmlns:a="http://schemas.openxmlformats.org/drawingml/2006/main"/>
           <a:p xmlns:a="http://schemas.openxmlformats.org/drawingml/2006/main">
             <a:pPr algn="l">
+              <a:buNone/>
               <a:defRPr sz="1650" b="0">
                 <a:solidFill>
                   <a:srgbClr val="172033"/>
@@ -8997,6 +9083,7 @@
           <a:lstStyle xmlns:a="http://schemas.openxmlformats.org/drawingml/2006/main"/>
           <a:p xmlns:a="http://schemas.openxmlformats.org/drawingml/2006/main">
             <a:pPr algn="ctr">
+              <a:buNone/>
               <a:defRPr sz="1350" b="1">
                 <a:solidFill>
                   <a:srgbClr val="233A70"/>
@@ -9115,6 +9202,7 @@
           <a:lstStyle xmlns:a="http://schemas.openxmlformats.org/drawingml/2006/main"/>
           <a:p xmlns:a="http://schemas.openxmlformats.org/drawingml/2006/main">
             <a:pPr algn="l">
+              <a:buNone/>
               <a:defRPr sz="3600" b="1">
                 <a:solidFill>
                   <a:srgbClr val="233A70"/>
@@ -9204,6 +9292,7 @@
           <a:lstStyle xmlns:a="http://schemas.openxmlformats.org/drawingml/2006/main"/>
           <a:p xmlns:a="http://schemas.openxmlformats.org/drawingml/2006/main">
             <a:pPr algn="l">
+              <a:buNone/>
               <a:defRPr sz="1050" b="0">
                 <a:solidFill>
                   <a:srgbClr val="5B6577"/>
@@ -9262,6 +9351,7 @@
           <a:lstStyle xmlns:a="http://schemas.openxmlformats.org/drawingml/2006/main"/>
           <a:p xmlns:a="http://schemas.openxmlformats.org/drawingml/2006/main">
             <a:pPr algn="r">
+              <a:buNone/>
               <a:defRPr sz="1050" b="0">
                 <a:solidFill>
                   <a:srgbClr val="5B6577"/>
@@ -9353,6 +9443,7 @@
           <a:lstStyle xmlns:a="http://schemas.openxmlformats.org/drawingml/2006/main"/>
           <a:p xmlns:a="http://schemas.openxmlformats.org/drawingml/2006/main">
             <a:pPr algn="ctr">
+              <a:buNone/>
               <a:defRPr sz="1425" b="1">
                 <a:solidFill>
                   <a:srgbClr val="BE3C37"/>
@@ -9614,6 +9705,7 @@
           <a:lstStyle xmlns:a="http://schemas.openxmlformats.org/drawingml/2006/main"/>
           <a:p xmlns:a="http://schemas.openxmlformats.org/drawingml/2006/main">
             <a:pPr algn="ctr">
+              <a:buNone/>
               <a:defRPr sz="1425" b="1">
                 <a:solidFill>
                   <a:srgbClr val="087A50"/>
@@ -9875,6 +9967,7 @@
           <a:lstStyle xmlns:a="http://schemas.openxmlformats.org/drawingml/2006/main"/>
           <a:p xmlns:a="http://schemas.openxmlformats.org/drawingml/2006/main">
             <a:pPr algn="ctr">
+              <a:buNone/>
               <a:defRPr sz="1575" b="1">
                 <a:solidFill>
                   <a:srgbClr val="FFFFFF"/>
@@ -9898,6 +9991,7 @@
           </a:p>
           <a:p xmlns:a="http://schemas.openxmlformats.org/drawingml/2006/main">
             <a:pPr algn="ctr">
+              <a:buNone/>
               <a:defRPr sz="1575" b="1">
                 <a:solidFill>
                   <a:srgbClr val="FFFFFF"/>
@@ -10016,6 +10110,7 @@
           <a:lstStyle xmlns:a="http://schemas.openxmlformats.org/drawingml/2006/main"/>
           <a:p xmlns:a="http://schemas.openxmlformats.org/drawingml/2006/main">
             <a:pPr algn="l">
+              <a:buNone/>
               <a:defRPr sz="3600" b="1">
                 <a:solidFill>
                   <a:srgbClr val="233A70"/>
@@ -10105,6 +10200,7 @@
           <a:lstStyle xmlns:a="http://schemas.openxmlformats.org/drawingml/2006/main"/>
           <a:p xmlns:a="http://schemas.openxmlformats.org/drawingml/2006/main">
             <a:pPr algn="l">
+              <a:buNone/>
               <a:defRPr sz="1050" b="0">
                 <a:solidFill>
                   <a:srgbClr val="5B6577"/>
@@ -10163,6 +10259,7 @@
           <a:lstStyle xmlns:a="http://schemas.openxmlformats.org/drawingml/2006/main"/>
           <a:p xmlns:a="http://schemas.openxmlformats.org/drawingml/2006/main">
             <a:pPr algn="r">
+              <a:buNone/>
               <a:defRPr sz="1050" b="0">
                 <a:solidFill>
                   <a:srgbClr val="5B6577"/>
@@ -10188,7 +10285,7 @@
       </p:sp>
       <p:graphicFrame>
         <p:nvGraphicFramePr>
-          <p:cNvPr id="14" name=""/>
+          <p:cNvPr id="16" name=""/>
           <p:cNvGraphicFramePr/>
           <p:nvPr/>
         </p:nvGraphicFramePr>
@@ -10214,7 +10311,9 @@
                     <a:bodyPr/>
                     <a:lstStyle/>
                     <a:p>
-                      <a:pPr algn="l"/>
+                      <a:pPr algn="l">
+                        <a:buNone/>
+                      </a:pPr>
                       <a:r>
                         <a:rPr sz="1425" b="1">
                           <a:solidFill>
@@ -10236,7 +10335,9 @@
                     <a:bodyPr/>
                     <a:lstStyle/>
                     <a:p>
-                      <a:pPr algn="ctr"/>
+                      <a:pPr algn="ctr">
+                        <a:buNone/>
+                      </a:pPr>
                       <a:r>
                         <a:rPr sz="1425" b="1">
                           <a:solidFill>
@@ -10258,7 +10359,9 @@
                     <a:bodyPr/>
                     <a:lstStyle/>
                     <a:p>
-                      <a:pPr algn="ctr"/>
+                      <a:pPr algn="ctr">
+                        <a:buNone/>
+                      </a:pPr>
                       <a:r>
                         <a:rPr sz="1425" b="1">
                           <a:solidFill>
@@ -10280,7 +10383,9 @@
                     <a:bodyPr/>
                     <a:lstStyle/>
                     <a:p>
-                      <a:pPr algn="ctr"/>
+                      <a:pPr algn="ctr">
+                        <a:buNone/>
+                      </a:pPr>
                       <a:r>
                         <a:rPr sz="1425" b="1">
                           <a:solidFill>
@@ -10302,7 +10407,9 @@
                     <a:bodyPr/>
                     <a:lstStyle/>
                     <a:p>
-                      <a:pPr algn="ctr"/>
+                      <a:pPr algn="ctr">
+                        <a:buNone/>
+                      </a:pPr>
                       <a:r>
                         <a:rPr sz="1425" b="1">
                           <a:solidFill>
@@ -10324,7 +10431,9 @@
                     <a:bodyPr/>
                     <a:lstStyle/>
                     <a:p>
-                      <a:pPr algn="ctr"/>
+                      <a:pPr algn="ctr">
+                        <a:buNone/>
+                      </a:pPr>
                       <a:r>
                         <a:rPr sz="1425" b="1">
                           <a:solidFill>
@@ -10348,7 +10457,9 @@
                     <a:bodyPr/>
                     <a:lstStyle/>
                     <a:p>
-                      <a:pPr algn="l"/>
+                      <a:pPr algn="l">
+                        <a:buNone/>
+                      </a:pPr>
                       <a:r>
                         <a:rPr sz="1425" b="1">
                           <a:solidFill>
@@ -10370,7 +10481,9 @@
                     <a:bodyPr/>
                     <a:lstStyle/>
                     <a:p>
-                      <a:pPr algn="ctr"/>
+                      <a:pPr algn="ctr">
+                        <a:buNone/>
+                      </a:pPr>
                       <a:r>
                         <a:rPr sz="1425" b="0">
                           <a:solidFill>
@@ -10392,7 +10505,9 @@
                     <a:bodyPr/>
                     <a:lstStyle/>
                     <a:p>
-                      <a:pPr algn="ctr"/>
+                      <a:pPr algn="ctr">
+                        <a:buNone/>
+                      </a:pPr>
                       <a:r>
                         <a:rPr sz="1425" b="0">
                           <a:solidFill>
@@ -10414,7 +10529,9 @@
                     <a:bodyPr/>
                     <a:lstStyle/>
                     <a:p>
-                      <a:pPr algn="ctr"/>
+                      <a:pPr algn="ctr">
+                        <a:buNone/>
+                      </a:pPr>
                       <a:r>
                         <a:rPr sz="1425" b="0">
                           <a:solidFill>
@@ -10436,7 +10553,9 @@
                     <a:bodyPr/>
                     <a:lstStyle/>
                     <a:p>
-                      <a:pPr algn="ctr"/>
+                      <a:pPr algn="ctr">
+                        <a:buNone/>
+                      </a:pPr>
                       <a:r>
                         <a:rPr sz="1425" b="0">
                           <a:solidFill>
@@ -10458,7 +10577,9 @@
                     <a:bodyPr/>
                     <a:lstStyle/>
                     <a:p>
-                      <a:pPr algn="ctr"/>
+                      <a:pPr algn="ctr">
+                        <a:buNone/>
+                      </a:pPr>
                       <a:r>
                         <a:rPr sz="1425" b="0">
                           <a:solidFill>
@@ -10482,7 +10603,9 @@
                     <a:bodyPr/>
                     <a:lstStyle/>
                     <a:p>
-                      <a:pPr algn="l"/>
+                      <a:pPr algn="l">
+                        <a:buNone/>
+                      </a:pPr>
                       <a:r>
                         <a:rPr sz="1425" b="1">
                           <a:solidFill>
@@ -10504,7 +10627,9 @@
                     <a:bodyPr/>
                     <a:lstStyle/>
                     <a:p>
-                      <a:pPr algn="ctr"/>
+                      <a:pPr algn="ctr">
+                        <a:buNone/>
+                      </a:pPr>
                       <a:r>
                         <a:rPr sz="1425" b="0">
                           <a:solidFill>
@@ -10526,7 +10651,9 @@
                     <a:bodyPr/>
                     <a:lstStyle/>
                     <a:p>
-                      <a:pPr algn="ctr"/>
+                      <a:pPr algn="ctr">
+                        <a:buNone/>
+                      </a:pPr>
                       <a:r>
                         <a:rPr sz="1425" b="0">
                           <a:solidFill>
@@ -10548,7 +10675,9 @@
                     <a:bodyPr/>
                     <a:lstStyle/>
                     <a:p>
-                      <a:pPr algn="ctr"/>
+                      <a:pPr algn="ctr">
+                        <a:buNone/>
+                      </a:pPr>
                       <a:r>
                         <a:rPr sz="1425" b="0">
                           <a:solidFill>
@@ -10570,7 +10699,9 @@
                     <a:bodyPr/>
                     <a:lstStyle/>
                     <a:p>
-                      <a:pPr algn="ctr"/>
+                      <a:pPr algn="ctr">
+                        <a:buNone/>
+                      </a:pPr>
                       <a:r>
                         <a:rPr sz="1425" b="0">
                           <a:solidFill>
@@ -10592,7 +10723,9 @@
                     <a:bodyPr/>
                     <a:lstStyle/>
                     <a:p>
-                      <a:pPr algn="ctr"/>
+                      <a:pPr algn="ctr">
+                        <a:buNone/>
+                      </a:pPr>
                       <a:r>
                         <a:rPr sz="1425" b="0">
                           <a:solidFill>
@@ -10616,7 +10749,9 @@
                     <a:bodyPr/>
                     <a:lstStyle/>
                     <a:p>
-                      <a:pPr algn="l"/>
+                      <a:pPr algn="l">
+                        <a:buNone/>
+                      </a:pPr>
                       <a:r>
                         <a:rPr sz="1425" b="1">
                           <a:solidFill>
@@ -10638,7 +10773,9 @@
                     <a:bodyPr/>
                     <a:lstStyle/>
                     <a:p>
-                      <a:pPr algn="ctr"/>
+                      <a:pPr algn="ctr">
+                        <a:buNone/>
+                      </a:pPr>
                       <a:r>
                         <a:rPr sz="1425" b="0">
                           <a:solidFill>
@@ -10660,7 +10797,9 @@
                     <a:bodyPr/>
                     <a:lstStyle/>
                     <a:p>
-                      <a:pPr algn="ctr"/>
+                      <a:pPr algn="ctr">
+                        <a:buNone/>
+                      </a:pPr>
                       <a:r>
                         <a:rPr sz="1425" b="0">
                           <a:solidFill>
@@ -10682,7 +10821,9 @@
                     <a:bodyPr/>
                     <a:lstStyle/>
                     <a:p>
-                      <a:pPr algn="ctr"/>
+                      <a:pPr algn="ctr">
+                        <a:buNone/>
+                      </a:pPr>
                       <a:r>
                         <a:rPr sz="1425" b="0">
                           <a:solidFill>
@@ -10704,7 +10845,9 @@
                     <a:bodyPr/>
                     <a:lstStyle/>
                     <a:p>
-                      <a:pPr algn="ctr"/>
+                      <a:pPr algn="ctr">
+                        <a:buNone/>
+                      </a:pPr>
                       <a:r>
                         <a:rPr sz="1425" b="0">
                           <a:solidFill>
@@ -10726,7 +10869,9 @@
                     <a:bodyPr/>
                     <a:lstStyle/>
                     <a:p>
-                      <a:pPr algn="ctr"/>
+                      <a:pPr algn="ctr">
+                        <a:buNone/>
+                      </a:pPr>
                       <a:r>
                         <a:rPr sz="1425" b="0">
                           <a:solidFill>
@@ -10750,7 +10895,9 @@
                     <a:bodyPr/>
                     <a:lstStyle/>
                     <a:p>
-                      <a:pPr algn="l"/>
+                      <a:pPr algn="l">
+                        <a:buNone/>
+                      </a:pPr>
                       <a:r>
                         <a:rPr sz="1425" b="1">
                           <a:solidFill>
@@ -10772,7 +10919,9 @@
                     <a:bodyPr/>
                     <a:lstStyle/>
                     <a:p>
-                      <a:pPr algn="ctr"/>
+                      <a:pPr algn="ctr">
+                        <a:buNone/>
+                      </a:pPr>
                       <a:r>
                         <a:rPr sz="1425" b="0">
                           <a:solidFill>
@@ -10794,7 +10943,9 @@
                     <a:bodyPr/>
                     <a:lstStyle/>
                     <a:p>
-                      <a:pPr algn="ctr"/>
+                      <a:pPr algn="ctr">
+                        <a:buNone/>
+                      </a:pPr>
                       <a:r>
                         <a:rPr sz="1425" b="0">
                           <a:solidFill>
@@ -10816,7 +10967,9 @@
                     <a:bodyPr/>
                     <a:lstStyle/>
                     <a:p>
-                      <a:pPr algn="ctr"/>
+                      <a:pPr algn="ctr">
+                        <a:buNone/>
+                      </a:pPr>
                       <a:r>
                         <a:rPr sz="1425" b="0">
                           <a:solidFill>
@@ -10838,7 +10991,9 @@
                     <a:bodyPr/>
                     <a:lstStyle/>
                     <a:p>
-                      <a:pPr algn="ctr"/>
+                      <a:pPr algn="ctr">
+                        <a:buNone/>
+                      </a:pPr>
                       <a:r>
                         <a:rPr sz="1425" b="0">
                           <a:solidFill>
@@ -10860,7 +11015,9 @@
                     <a:bodyPr/>
                     <a:lstStyle/>
                     <a:p>
-                      <a:pPr algn="ctr"/>
+                      <a:pPr algn="ctr">
+                        <a:buNone/>
+                      </a:pPr>
                       <a:r>
                         <a:rPr sz="1425" b="0">
                           <a:solidFill>
@@ -10884,7 +11041,9 @@
                     <a:bodyPr/>
                     <a:lstStyle/>
                     <a:p>
-                      <a:pPr algn="l"/>
+                      <a:pPr algn="l">
+                        <a:buNone/>
+                      </a:pPr>
                       <a:r>
                         <a:rPr sz="1425" b="1">
                           <a:solidFill>
@@ -10906,7 +11065,9 @@
                     <a:bodyPr/>
                     <a:lstStyle/>
                     <a:p>
-                      <a:pPr algn="ctr"/>
+                      <a:pPr algn="ctr">
+                        <a:buNone/>
+                      </a:pPr>
                       <a:r>
                         <a:rPr sz="1425" b="0">
                           <a:solidFill>
@@ -10928,7 +11089,9 @@
                     <a:bodyPr/>
                     <a:lstStyle/>
                     <a:p>
-                      <a:pPr algn="ctr"/>
+                      <a:pPr algn="ctr">
+                        <a:buNone/>
+                      </a:pPr>
                       <a:r>
                         <a:rPr sz="1425" b="0">
                           <a:solidFill>
@@ -10950,7 +11113,9 @@
                     <a:bodyPr/>
                     <a:lstStyle/>
                     <a:p>
-                      <a:pPr algn="ctr"/>
+                      <a:pPr algn="ctr">
+                        <a:buNone/>
+                      </a:pPr>
                       <a:r>
                         <a:rPr sz="1425" b="0">
                           <a:solidFill>
@@ -10972,7 +11137,9 @@
                     <a:bodyPr/>
                     <a:lstStyle/>
                     <a:p>
-                      <a:pPr algn="ctr"/>
+                      <a:pPr algn="ctr">
+                        <a:buNone/>
+                      </a:pPr>
                       <a:r>
                         <a:rPr sz="1425" b="0">
                           <a:solidFill>
@@ -10994,7 +11161,9 @@
                     <a:bodyPr/>
                     <a:lstStyle/>
                     <a:p>
-                      <a:pPr algn="ctr"/>
+                      <a:pPr algn="ctr">
+                        <a:buNone/>
+                      </a:pPr>
                       <a:r>
                         <a:rPr sz="1425" b="0">
                           <a:solidFill>
@@ -11018,7 +11187,9 @@
                     <a:bodyPr/>
                     <a:lstStyle/>
                     <a:p>
-                      <a:pPr algn="l"/>
+                      <a:pPr algn="l">
+                        <a:buNone/>
+                      </a:pPr>
                       <a:r>
                         <a:rPr sz="1425" b="1">
                           <a:solidFill>
@@ -11040,7 +11211,9 @@
                     <a:bodyPr/>
                     <a:lstStyle/>
                     <a:p>
-                      <a:pPr algn="ctr"/>
+                      <a:pPr algn="ctr">
+                        <a:buNone/>
+                      </a:pPr>
                       <a:r>
                         <a:rPr sz="1425" b="0">
                           <a:solidFill>
@@ -11062,7 +11235,9 @@
                     <a:bodyPr/>
                     <a:lstStyle/>
                     <a:p>
-                      <a:pPr algn="ctr"/>
+                      <a:pPr algn="ctr">
+                        <a:buNone/>
+                      </a:pPr>
                       <a:r>
                         <a:rPr sz="1425" b="0">
                           <a:solidFill>
@@ -11084,7 +11259,9 @@
                     <a:bodyPr/>
                     <a:lstStyle/>
                     <a:p>
-                      <a:pPr algn="ctr"/>
+                      <a:pPr algn="ctr">
+                        <a:buNone/>
+                      </a:pPr>
                       <a:r>
                         <a:rPr sz="1425" b="0">
                           <a:solidFill>
@@ -11106,7 +11283,9 @@
                     <a:bodyPr/>
                     <a:lstStyle/>
                     <a:p>
-                      <a:pPr algn="ctr"/>
+                      <a:pPr algn="ctr">
+                        <a:buNone/>
+                      </a:pPr>
                       <a:r>
                         <a:rPr sz="1425" b="0">
                           <a:solidFill>
@@ -11128,7 +11307,9 @@
                     <a:bodyPr/>
                     <a:lstStyle/>
                     <a:p>
-                      <a:pPr algn="ctr"/>
+                      <a:pPr algn="ctr">
+                        <a:buNone/>
+                      </a:pPr>
                       <a:r>
                         <a:rPr sz="1425" b="0">
                           <a:solidFill>
@@ -11218,6 +11399,7 @@
           <a:lstStyle xmlns:a="http://schemas.openxmlformats.org/drawingml/2006/main"/>
           <a:p xmlns:a="http://schemas.openxmlformats.org/drawingml/2006/main">
             <a:pPr algn="ctr">
+              <a:buNone/>
               <a:defRPr sz="1425" b="1">
                 <a:solidFill>
                   <a:srgbClr val="172033"/>
@@ -11336,6 +11518,7 @@
           <a:lstStyle xmlns:a="http://schemas.openxmlformats.org/drawingml/2006/main"/>
           <a:p xmlns:a="http://schemas.openxmlformats.org/drawingml/2006/main">
             <a:pPr algn="l">
+              <a:buNone/>
               <a:defRPr sz="3600" b="1">
                 <a:solidFill>
                   <a:srgbClr val="233A70"/>
@@ -11425,6 +11608,7 @@
           <a:lstStyle xmlns:a="http://schemas.openxmlformats.org/drawingml/2006/main"/>
           <a:p xmlns:a="http://schemas.openxmlformats.org/drawingml/2006/main">
             <a:pPr algn="l">
+              <a:buNone/>
               <a:defRPr sz="1050" b="0">
                 <a:solidFill>
                   <a:srgbClr val="5B6577"/>
@@ -11483,6 +11667,7 @@
           <a:lstStyle xmlns:a="http://schemas.openxmlformats.org/drawingml/2006/main"/>
           <a:p xmlns:a="http://schemas.openxmlformats.org/drawingml/2006/main">
             <a:pPr algn="r">
+              <a:buNone/>
               <a:defRPr sz="1050" b="0">
                 <a:solidFill>
                   <a:srgbClr val="5B6577"/>
@@ -11607,6 +11792,7 @@
           <a:lstStyle xmlns:a="http://schemas.openxmlformats.org/drawingml/2006/main"/>
           <a:p xmlns:a="http://schemas.openxmlformats.org/drawingml/2006/main">
             <a:pPr algn="ctr">
+              <a:buNone/>
               <a:defRPr sz="1275" b="1">
                 <a:solidFill>
                   <a:srgbClr val="233A70"/>
@@ -11665,6 +11851,7 @@
           <a:lstStyle xmlns:a="http://schemas.openxmlformats.org/drawingml/2006/main"/>
           <a:p xmlns:a="http://schemas.openxmlformats.org/drawingml/2006/main">
             <a:pPr algn="ctr">
+              <a:buNone/>
               <a:defRPr sz="1275" b="0">
                 <a:solidFill>
                   <a:srgbClr val="5B6577"/>
@@ -11688,6 +11875,7 @@
           </a:p>
           <a:p xmlns:a="http://schemas.openxmlformats.org/drawingml/2006/main">
             <a:pPr algn="ctr">
+              <a:buNone/>
               <a:defRPr sz="1275" b="0">
                 <a:solidFill>
                   <a:srgbClr val="5B6577"/>
@@ -11781,6 +11969,7 @@
           <a:lstStyle xmlns:a="http://schemas.openxmlformats.org/drawingml/2006/main"/>
           <a:p xmlns:a="http://schemas.openxmlformats.org/drawingml/2006/main">
             <a:pPr algn="ctr">
+              <a:buNone/>
               <a:defRPr sz="1275" b="1">
                 <a:solidFill>
                   <a:srgbClr val="233A70"/>
@@ -11839,6 +12028,7 @@
           <a:lstStyle xmlns:a="http://schemas.openxmlformats.org/drawingml/2006/main"/>
           <a:p xmlns:a="http://schemas.openxmlformats.org/drawingml/2006/main">
             <a:pPr algn="ctr">
+              <a:buNone/>
               <a:defRPr sz="1275" b="0">
                 <a:solidFill>
                   <a:srgbClr val="5B6577"/>
@@ -11862,6 +12052,7 @@
           </a:p>
           <a:p xmlns:a="http://schemas.openxmlformats.org/drawingml/2006/main">
             <a:pPr algn="ctr">
+              <a:buNone/>
               <a:defRPr sz="1275" b="0">
                 <a:solidFill>
                   <a:srgbClr val="5B6577"/>
@@ -11955,6 +12146,7 @@
           <a:lstStyle xmlns:a="http://schemas.openxmlformats.org/drawingml/2006/main"/>
           <a:p xmlns:a="http://schemas.openxmlformats.org/drawingml/2006/main">
             <a:pPr algn="ctr">
+              <a:buNone/>
               <a:defRPr sz="1275" b="1">
                 <a:solidFill>
                   <a:srgbClr val="087A50"/>
@@ -12013,6 +12205,7 @@
           <a:lstStyle xmlns:a="http://schemas.openxmlformats.org/drawingml/2006/main"/>
           <a:p xmlns:a="http://schemas.openxmlformats.org/drawingml/2006/main">
             <a:pPr algn="ctr">
+              <a:buNone/>
               <a:defRPr sz="1275" b="0">
                 <a:solidFill>
                   <a:srgbClr val="5B6577"/>
@@ -12036,6 +12229,7 @@
           </a:p>
           <a:p xmlns:a="http://schemas.openxmlformats.org/drawingml/2006/main">
             <a:pPr algn="ctr">
+              <a:buNone/>
               <a:defRPr sz="1275" b="0">
                 <a:solidFill>
                   <a:srgbClr val="5B6577"/>
@@ -12129,6 +12323,7 @@
           <a:lstStyle xmlns:a="http://schemas.openxmlformats.org/drawingml/2006/main"/>
           <a:p xmlns:a="http://schemas.openxmlformats.org/drawingml/2006/main">
             <a:pPr algn="ctr">
+              <a:buNone/>
               <a:defRPr sz="1275" b="1">
                 <a:solidFill>
                   <a:srgbClr val="233A70"/>
@@ -12187,6 +12382,7 @@
           <a:lstStyle xmlns:a="http://schemas.openxmlformats.org/drawingml/2006/main"/>
           <a:p xmlns:a="http://schemas.openxmlformats.org/drawingml/2006/main">
             <a:pPr algn="ctr">
+              <a:buNone/>
               <a:defRPr sz="1275" b="0">
                 <a:solidFill>
                   <a:srgbClr val="5B6577"/>
@@ -12210,6 +12406,7 @@
           </a:p>
           <a:p xmlns:a="http://schemas.openxmlformats.org/drawingml/2006/main">
             <a:pPr algn="ctr">
+              <a:buNone/>
               <a:defRPr sz="1275" b="0">
                 <a:solidFill>
                   <a:srgbClr val="5B6577"/>
@@ -12303,6 +12500,7 @@
           <a:lstStyle xmlns:a="http://schemas.openxmlformats.org/drawingml/2006/main"/>
           <a:p xmlns:a="http://schemas.openxmlformats.org/drawingml/2006/main">
             <a:pPr algn="ctr">
+              <a:buNone/>
               <a:defRPr sz="1275" b="1">
                 <a:solidFill>
                   <a:srgbClr val="233A70"/>
@@ -12361,6 +12559,7 @@
           <a:lstStyle xmlns:a="http://schemas.openxmlformats.org/drawingml/2006/main"/>
           <a:p xmlns:a="http://schemas.openxmlformats.org/drawingml/2006/main">
             <a:pPr algn="ctr">
+              <a:buNone/>
               <a:defRPr sz="1275" b="0">
                 <a:solidFill>
                   <a:srgbClr val="5B6577"/>
@@ -12384,6 +12583,7 @@
           </a:p>
           <a:p xmlns:a="http://schemas.openxmlformats.org/drawingml/2006/main">
             <a:pPr algn="ctr">
+              <a:buNone/>
               <a:defRPr sz="1275" b="0">
                 <a:solidFill>
                   <a:srgbClr val="5B6577"/>
@@ -12442,6 +12642,7 @@
           <a:lstStyle xmlns:a="http://schemas.openxmlformats.org/drawingml/2006/main"/>
           <a:p xmlns:a="http://schemas.openxmlformats.org/drawingml/2006/main">
             <a:pPr algn="ctr">
+              <a:buNone/>
               <a:defRPr sz="1650" b="1">
                 <a:solidFill>
                   <a:srgbClr val="233A70"/>
@@ -12703,6 +12904,7 @@
           <a:lstStyle xmlns:a="http://schemas.openxmlformats.org/drawingml/2006/main"/>
           <a:p xmlns:a="http://schemas.openxmlformats.org/drawingml/2006/main">
             <a:pPr algn="l">
+              <a:buNone/>
               <a:defRPr sz="3600" b="1">
                 <a:solidFill>
                   <a:srgbClr val="233A70"/>
@@ -12792,6 +12994,7 @@
           <a:lstStyle xmlns:a="http://schemas.openxmlformats.org/drawingml/2006/main"/>
           <a:p xmlns:a="http://schemas.openxmlformats.org/drawingml/2006/main">
             <a:pPr algn="l">
+              <a:buNone/>
               <a:defRPr sz="1050" b="0">
                 <a:solidFill>
                   <a:srgbClr val="5B6577"/>
@@ -12850,6 +13053,7 @@
           <a:lstStyle xmlns:a="http://schemas.openxmlformats.org/drawingml/2006/main"/>
           <a:p xmlns:a="http://schemas.openxmlformats.org/drawingml/2006/main">
             <a:pPr algn="r">
+              <a:buNone/>
               <a:defRPr sz="1050" b="0">
                 <a:solidFill>
                   <a:srgbClr val="5B6577"/>
@@ -12941,6 +13145,7 @@
           <a:lstStyle xmlns:a="http://schemas.openxmlformats.org/drawingml/2006/main"/>
           <a:p xmlns:a="http://schemas.openxmlformats.org/drawingml/2006/main">
             <a:pPr algn="ctr">
+              <a:buNone/>
               <a:defRPr sz="1350" b="1">
                 <a:solidFill>
                   <a:srgbClr val="14B978"/>
@@ -12999,6 +13204,7 @@
           <a:lstStyle xmlns:a="http://schemas.openxmlformats.org/drawingml/2006/main"/>
           <a:p xmlns:a="http://schemas.openxmlformats.org/drawingml/2006/main">
             <a:pPr algn="ctr">
+              <a:buNone/>
               <a:defRPr sz="4200" b="1">
                 <a:solidFill>
                   <a:srgbClr val="FFFFFF"/>
@@ -13057,6 +13263,7 @@
           <a:lstStyle xmlns:a="http://schemas.openxmlformats.org/drawingml/2006/main"/>
           <a:p xmlns:a="http://schemas.openxmlformats.org/drawingml/2006/main">
             <a:pPr algn="ctr">
+              <a:buNone/>
               <a:defRPr sz="1650" b="1">
                 <a:solidFill>
                   <a:srgbClr val="FFFFFF"/>
@@ -13115,6 +13322,7 @@
           <a:lstStyle xmlns:a="http://schemas.openxmlformats.org/drawingml/2006/main"/>
           <a:p xmlns:a="http://schemas.openxmlformats.org/drawingml/2006/main">
             <a:pPr algn="ctr">
+              <a:buNone/>
               <a:defRPr sz="1425" b="0">
                 <a:solidFill>
                   <a:srgbClr val="DCE4F3"/>
@@ -13204,6 +13412,7 @@
           <a:lstStyle xmlns:a="http://schemas.openxmlformats.org/drawingml/2006/main"/>
           <a:p xmlns:a="http://schemas.openxmlformats.org/drawingml/2006/main">
             <a:pPr algn="ctr">
+              <a:buNone/>
               <a:defRPr sz="1575" b="1">
                 <a:solidFill>
                   <a:srgbClr val="FFFFFF"/>
@@ -13262,6 +13471,7 @@
           <a:lstStyle xmlns:a="http://schemas.openxmlformats.org/drawingml/2006/main"/>
           <a:p xmlns:a="http://schemas.openxmlformats.org/drawingml/2006/main">
             <a:pPr algn="ctr">
+              <a:buNone/>
               <a:defRPr sz="1350" b="0">
                 <a:solidFill>
                   <a:srgbClr val="FFF4CD"/>
@@ -13320,6 +13530,7 @@
           <a:lstStyle xmlns:a="http://schemas.openxmlformats.org/drawingml/2006/main"/>
           <a:p xmlns:a="http://schemas.openxmlformats.org/drawingml/2006/main">
             <a:pPr algn="l">
+              <a:buNone/>
               <a:defRPr sz="1425" b="1">
                 <a:solidFill>
                   <a:srgbClr val="233A70"/>
@@ -13378,6 +13589,7 @@
           <a:lstStyle xmlns:a="http://schemas.openxmlformats.org/drawingml/2006/main"/>
           <a:p xmlns:a="http://schemas.openxmlformats.org/drawingml/2006/main">
             <a:pPr algn="l">
+              <a:buNone/>
               <a:defRPr sz="1500" b="1">
                 <a:solidFill>
                   <a:srgbClr val="233A70"/>
@@ -13436,6 +13648,7 @@
           <a:lstStyle xmlns:a="http://schemas.openxmlformats.org/drawingml/2006/main"/>
           <a:p xmlns:a="http://schemas.openxmlformats.org/drawingml/2006/main">
             <a:pPr algn="l">
+              <a:buNone/>
               <a:defRPr sz="1425" b="0">
                 <a:solidFill>
                   <a:srgbClr val="172033"/>
@@ -13525,6 +13738,7 @@
           <a:lstStyle xmlns:a="http://schemas.openxmlformats.org/drawingml/2006/main"/>
           <a:p xmlns:a="http://schemas.openxmlformats.org/drawingml/2006/main">
             <a:pPr algn="l">
+              <a:buNone/>
               <a:defRPr sz="1500" b="1">
                 <a:solidFill>
                   <a:srgbClr val="233A70"/>
@@ -13583,6 +13797,7 @@
           <a:lstStyle xmlns:a="http://schemas.openxmlformats.org/drawingml/2006/main"/>
           <a:p xmlns:a="http://schemas.openxmlformats.org/drawingml/2006/main">
             <a:pPr algn="l">
+              <a:buNone/>
               <a:defRPr sz="1425" b="0">
                 <a:solidFill>
                   <a:srgbClr val="172033"/>
@@ -13672,6 +13887,7 @@
           <a:lstStyle xmlns:a="http://schemas.openxmlformats.org/drawingml/2006/main"/>
           <a:p xmlns:a="http://schemas.openxmlformats.org/drawingml/2006/main">
             <a:pPr algn="l">
+              <a:buNone/>
               <a:defRPr sz="1500" b="1">
                 <a:solidFill>
                   <a:srgbClr val="233A70"/>
@@ -13730,6 +13946,7 @@
           <a:lstStyle xmlns:a="http://schemas.openxmlformats.org/drawingml/2006/main"/>
           <a:p xmlns:a="http://schemas.openxmlformats.org/drawingml/2006/main">
             <a:pPr algn="l">
+              <a:buNone/>
               <a:defRPr sz="1425" b="0">
                 <a:solidFill>
                   <a:srgbClr val="172033"/>
@@ -13819,6 +14036,7 @@
           <a:lstStyle xmlns:a="http://schemas.openxmlformats.org/drawingml/2006/main"/>
           <a:p xmlns:a="http://schemas.openxmlformats.org/drawingml/2006/main">
             <a:pPr algn="l">
+              <a:buNone/>
               <a:defRPr sz="1500" b="1">
                 <a:solidFill>
                   <a:srgbClr val="233A70"/>
@@ -13877,6 +14095,7 @@
           <a:lstStyle xmlns:a="http://schemas.openxmlformats.org/drawingml/2006/main"/>
           <a:p xmlns:a="http://schemas.openxmlformats.org/drawingml/2006/main">
             <a:pPr algn="l">
+              <a:buNone/>
               <a:defRPr sz="1425" b="0">
                 <a:solidFill>
                   <a:srgbClr val="172033"/>
@@ -13966,6 +14185,7 @@
           <a:lstStyle xmlns:a="http://schemas.openxmlformats.org/drawingml/2006/main"/>
           <a:p xmlns:a="http://schemas.openxmlformats.org/drawingml/2006/main">
             <a:pPr algn="l">
+              <a:buNone/>
               <a:defRPr sz="1500" b="1">
                 <a:solidFill>
                   <a:srgbClr val="BE3C37"/>
@@ -14024,6 +14244,7 @@
           <a:lstStyle xmlns:a="http://schemas.openxmlformats.org/drawingml/2006/main"/>
           <a:p xmlns:a="http://schemas.openxmlformats.org/drawingml/2006/main">
             <a:pPr algn="l">
+              <a:buNone/>
               <a:defRPr sz="1425" b="0">
                 <a:solidFill>
                   <a:srgbClr val="172033"/>
@@ -14115,6 +14336,7 @@
           <a:lstStyle xmlns:a="http://schemas.openxmlformats.org/drawingml/2006/main"/>
           <a:p xmlns:a="http://schemas.openxmlformats.org/drawingml/2006/main">
             <a:pPr algn="ctr">
+              <a:buNone/>
               <a:defRPr sz="1350" b="1">
                 <a:solidFill>
                   <a:srgbClr val="233A70"/>
@@ -14233,6 +14455,7 @@
           <a:lstStyle xmlns:a="http://schemas.openxmlformats.org/drawingml/2006/main"/>
           <a:p xmlns:a="http://schemas.openxmlformats.org/drawingml/2006/main">
             <a:pPr algn="l">
+              <a:buNone/>
               <a:defRPr sz="3600" b="1">
                 <a:solidFill>
                   <a:srgbClr val="233A70"/>
@@ -14322,6 +14545,7 @@
           <a:lstStyle xmlns:a="http://schemas.openxmlformats.org/drawingml/2006/main"/>
           <a:p xmlns:a="http://schemas.openxmlformats.org/drawingml/2006/main">
             <a:pPr algn="l">
+              <a:buNone/>
               <a:defRPr sz="1050" b="0">
                 <a:solidFill>
                   <a:srgbClr val="5B6577"/>
@@ -14380,6 +14604,7 @@
           <a:lstStyle xmlns:a="http://schemas.openxmlformats.org/drawingml/2006/main"/>
           <a:p xmlns:a="http://schemas.openxmlformats.org/drawingml/2006/main">
             <a:pPr algn="r">
+              <a:buNone/>
               <a:defRPr sz="1050" b="0">
                 <a:solidFill>
                   <a:srgbClr val="5B6577"/>
@@ -14473,6 +14698,7 @@
           <a:lstStyle xmlns:a="http://schemas.openxmlformats.org/drawingml/2006/main"/>
           <a:p xmlns:a="http://schemas.openxmlformats.org/drawingml/2006/main">
             <a:pPr algn="ctr">
+              <a:buNone/>
               <a:defRPr sz="2850" b="1">
                 <a:solidFill>
                   <a:srgbClr val="233A70"/>
@@ -14531,6 +14757,7 @@
           <a:lstStyle xmlns:a="http://schemas.openxmlformats.org/drawingml/2006/main"/>
           <a:p xmlns:a="http://schemas.openxmlformats.org/drawingml/2006/main">
             <a:pPr algn="ctr">
+              <a:buNone/>
               <a:defRPr sz="1500" b="0">
                 <a:solidFill>
                   <a:srgbClr val="5B6577"/>
@@ -14624,6 +14851,7 @@
           <a:lstStyle xmlns:a="http://schemas.openxmlformats.org/drawingml/2006/main"/>
           <a:p xmlns:a="http://schemas.openxmlformats.org/drawingml/2006/main">
             <a:pPr algn="ctr">
+              <a:buNone/>
               <a:defRPr sz="2850" b="1">
                 <a:solidFill>
                   <a:srgbClr val="233A70"/>
@@ -14682,6 +14910,7 @@
           <a:lstStyle xmlns:a="http://schemas.openxmlformats.org/drawingml/2006/main"/>
           <a:p xmlns:a="http://schemas.openxmlformats.org/drawingml/2006/main">
             <a:pPr algn="ctr">
+              <a:buNone/>
               <a:defRPr sz="1500" b="0">
                 <a:solidFill>
                   <a:srgbClr val="5B6577"/>
@@ -14775,6 +15004,7 @@
           <a:lstStyle xmlns:a="http://schemas.openxmlformats.org/drawingml/2006/main"/>
           <a:p xmlns:a="http://schemas.openxmlformats.org/drawingml/2006/main">
             <a:pPr algn="ctr">
+              <a:buNone/>
               <a:defRPr sz="2850" b="1">
                 <a:solidFill>
                   <a:srgbClr val="BE3C37"/>
@@ -14833,6 +15063,7 @@
           <a:lstStyle xmlns:a="http://schemas.openxmlformats.org/drawingml/2006/main"/>
           <a:p xmlns:a="http://schemas.openxmlformats.org/drawingml/2006/main">
             <a:pPr algn="ctr">
+              <a:buNone/>
               <a:defRPr sz="1500" b="0">
                 <a:solidFill>
                   <a:srgbClr val="5B6577"/>
@@ -14891,6 +15122,7 @@
           <a:lstStyle xmlns:a="http://schemas.openxmlformats.org/drawingml/2006/main"/>
           <a:p xmlns:a="http://schemas.openxmlformats.org/drawingml/2006/main">
             <a:pPr algn="ctr">
+              <a:buNone/>
               <a:defRPr sz="3150" b="1">
                 <a:solidFill>
                   <a:srgbClr val="233A70"/>
@@ -14949,6 +15181,7 @@
           <a:lstStyle xmlns:a="http://schemas.openxmlformats.org/drawingml/2006/main"/>
           <a:p xmlns:a="http://schemas.openxmlformats.org/drawingml/2006/main">
             <a:pPr algn="ctr">
+              <a:buNone/>
               <a:defRPr sz="3150" b="1">
                 <a:solidFill>
                   <a:srgbClr val="233A70"/>
@@ -15040,6 +15273,7 @@
           <a:lstStyle xmlns:a="http://schemas.openxmlformats.org/drawingml/2006/main"/>
           <a:p xmlns:a="http://schemas.openxmlformats.org/drawingml/2006/main">
             <a:pPr algn="ctr">
+              <a:buNone/>
               <a:defRPr sz="2400" b="1">
                 <a:solidFill>
                   <a:srgbClr val="FFFFFF"/>
@@ -15063,6 +15297,7 @@
           </a:p>
           <a:p xmlns:a="http://schemas.openxmlformats.org/drawingml/2006/main">
             <a:pPr algn="ctr">
+              <a:buNone/>
               <a:defRPr sz="2400" b="1">
                 <a:solidFill>
                   <a:srgbClr val="FFFFFF"/>
@@ -15121,6 +15356,7 @@
           <a:lstStyle xmlns:a="http://schemas.openxmlformats.org/drawingml/2006/main"/>
           <a:p xmlns:a="http://schemas.openxmlformats.org/drawingml/2006/main">
             <a:pPr algn="ctr">
+              <a:buNone/>
               <a:defRPr sz="1575" b="0">
                 <a:solidFill>
                   <a:srgbClr val="5B6577"/>
@@ -15212,6 +15448,7 @@
           <a:lstStyle xmlns:a="http://schemas.openxmlformats.org/drawingml/2006/main"/>
           <a:p xmlns:a="http://schemas.openxmlformats.org/drawingml/2006/main">
             <a:pPr algn="ctr">
+              <a:buNone/>
               <a:defRPr sz="1425" b="1">
                 <a:solidFill>
                   <a:srgbClr val="087A50"/>
@@ -15330,6 +15567,7 @@
           <a:lstStyle xmlns:a="http://schemas.openxmlformats.org/drawingml/2006/main"/>
           <a:p xmlns:a="http://schemas.openxmlformats.org/drawingml/2006/main">
             <a:pPr algn="l">
+              <a:buNone/>
               <a:defRPr sz="3600" b="1">
                 <a:solidFill>
                   <a:srgbClr val="233A70"/>
@@ -15419,6 +15657,7 @@
           <a:lstStyle xmlns:a="http://schemas.openxmlformats.org/drawingml/2006/main"/>
           <a:p xmlns:a="http://schemas.openxmlformats.org/drawingml/2006/main">
             <a:pPr algn="l">
+              <a:buNone/>
               <a:defRPr sz="1050" b="0">
                 <a:solidFill>
                   <a:srgbClr val="5B6577"/>
@@ -15477,6 +15716,7 @@
           <a:lstStyle xmlns:a="http://schemas.openxmlformats.org/drawingml/2006/main"/>
           <a:p xmlns:a="http://schemas.openxmlformats.org/drawingml/2006/main">
             <a:pPr algn="r">
+              <a:buNone/>
               <a:defRPr sz="1050" b="0">
                 <a:solidFill>
                   <a:srgbClr val="5B6577"/>
@@ -15570,6 +15810,7 @@
           <a:lstStyle xmlns:a="http://schemas.openxmlformats.org/drawingml/2006/main"/>
           <a:p xmlns:a="http://schemas.openxmlformats.org/drawingml/2006/main">
             <a:pPr algn="ctr">
+              <a:buNone/>
               <a:defRPr sz="1350" b="1">
                 <a:solidFill>
                   <a:srgbClr val="233A70"/>
@@ -15628,6 +15869,7 @@
           <a:lstStyle xmlns:a="http://schemas.openxmlformats.org/drawingml/2006/main"/>
           <a:p xmlns:a="http://schemas.openxmlformats.org/drawingml/2006/main">
             <a:pPr algn="ctr">
+              <a:buNone/>
               <a:defRPr sz="1800" b="1">
                 <a:solidFill>
                   <a:srgbClr val="172033"/>
@@ -15721,6 +15963,7 @@
           <a:lstStyle xmlns:a="http://schemas.openxmlformats.org/drawingml/2006/main"/>
           <a:p xmlns:a="http://schemas.openxmlformats.org/drawingml/2006/main">
             <a:pPr algn="ctr">
+              <a:buNone/>
               <a:defRPr sz="1350" b="1">
                 <a:solidFill>
                   <a:srgbClr val="087A50"/>
@@ -15779,6 +16022,7 @@
           <a:lstStyle xmlns:a="http://schemas.openxmlformats.org/drawingml/2006/main"/>
           <a:p xmlns:a="http://schemas.openxmlformats.org/drawingml/2006/main">
             <a:pPr algn="ctr">
+              <a:buNone/>
               <a:defRPr sz="1800" b="1">
                 <a:solidFill>
                   <a:srgbClr val="172033"/>
@@ -15872,6 +16116,7 @@
           <a:lstStyle xmlns:a="http://schemas.openxmlformats.org/drawingml/2006/main"/>
           <a:p xmlns:a="http://schemas.openxmlformats.org/drawingml/2006/main">
             <a:pPr algn="ctr">
+              <a:buNone/>
               <a:defRPr sz="1350" b="1">
                 <a:solidFill>
                   <a:srgbClr val="233A70"/>
@@ -15930,6 +16175,7 @@
           <a:lstStyle xmlns:a="http://schemas.openxmlformats.org/drawingml/2006/main"/>
           <a:p xmlns:a="http://schemas.openxmlformats.org/drawingml/2006/main">
             <a:pPr algn="ctr">
+              <a:buNone/>
               <a:defRPr sz="1800" b="1">
                 <a:solidFill>
                   <a:srgbClr val="172033"/>
@@ -16023,6 +16269,7 @@
           <a:lstStyle xmlns:a="http://schemas.openxmlformats.org/drawingml/2006/main"/>
           <a:p xmlns:a="http://schemas.openxmlformats.org/drawingml/2006/main">
             <a:pPr algn="ctr">
+              <a:buNone/>
               <a:defRPr sz="1350" b="1">
                 <a:solidFill>
                   <a:srgbClr val="C89B14"/>
@@ -16081,6 +16328,7 @@
           <a:lstStyle xmlns:a="http://schemas.openxmlformats.org/drawingml/2006/main"/>
           <a:p xmlns:a="http://schemas.openxmlformats.org/drawingml/2006/main">
             <a:pPr algn="ctr">
+              <a:buNone/>
               <a:defRPr sz="1800" b="1">
                 <a:solidFill>
                   <a:srgbClr val="172033"/>
@@ -16174,6 +16422,7 @@
           <a:lstStyle xmlns:a="http://schemas.openxmlformats.org/drawingml/2006/main"/>
           <a:p xmlns:a="http://schemas.openxmlformats.org/drawingml/2006/main">
             <a:pPr algn="ctr">
+              <a:buNone/>
               <a:defRPr sz="1350" b="1">
                 <a:solidFill>
                   <a:srgbClr val="233A70"/>
@@ -16232,6 +16481,7 @@
           <a:lstStyle xmlns:a="http://schemas.openxmlformats.org/drawingml/2006/main"/>
           <a:p xmlns:a="http://schemas.openxmlformats.org/drawingml/2006/main">
             <a:pPr algn="ctr">
+              <a:buNone/>
               <a:defRPr sz="1800" b="1">
                 <a:solidFill>
                   <a:srgbClr val="172033"/>
@@ -16325,6 +16575,7 @@
           <a:lstStyle xmlns:a="http://schemas.openxmlformats.org/drawingml/2006/main"/>
           <a:p xmlns:a="http://schemas.openxmlformats.org/drawingml/2006/main">
             <a:pPr algn="ctr">
+              <a:buNone/>
               <a:defRPr sz="1350" b="1">
                 <a:solidFill>
                   <a:srgbClr val="087A50"/>
@@ -16383,6 +16634,7 @@
           <a:lstStyle xmlns:a="http://schemas.openxmlformats.org/drawingml/2006/main"/>
           <a:p xmlns:a="http://schemas.openxmlformats.org/drawingml/2006/main">
             <a:pPr algn="ctr">
+              <a:buNone/>
               <a:defRPr sz="1800" b="1">
                 <a:solidFill>
                   <a:srgbClr val="172033"/>
@@ -16441,6 +16693,7 @@
           <a:lstStyle xmlns:a="http://schemas.openxmlformats.org/drawingml/2006/main"/>
           <a:p xmlns:a="http://schemas.openxmlformats.org/drawingml/2006/main">
             <a:pPr algn="ctr">
+              <a:buNone/>
               <a:defRPr sz="3000" b="1">
                 <a:solidFill>
                   <a:srgbClr val="233A70"/>
@@ -16499,6 +16752,7 @@
           <a:lstStyle xmlns:a="http://schemas.openxmlformats.org/drawingml/2006/main"/>
           <a:p xmlns:a="http://schemas.openxmlformats.org/drawingml/2006/main">
             <a:pPr algn="ctr">
+              <a:buNone/>
               <a:defRPr sz="3000" b="1">
                 <a:solidFill>
                   <a:srgbClr val="233A70"/>
@@ -16557,6 +16811,7 @@
           <a:lstStyle xmlns:a="http://schemas.openxmlformats.org/drawingml/2006/main"/>
           <a:p xmlns:a="http://schemas.openxmlformats.org/drawingml/2006/main">
             <a:pPr algn="ctr">
+              <a:buNone/>
               <a:defRPr sz="3000" b="1">
                 <a:solidFill>
                   <a:srgbClr val="233A70"/>
@@ -16615,6 +16870,7 @@
           <a:lstStyle xmlns:a="http://schemas.openxmlformats.org/drawingml/2006/main"/>
           <a:p xmlns:a="http://schemas.openxmlformats.org/drawingml/2006/main">
             <a:pPr algn="ctr">
+              <a:buNone/>
               <a:defRPr sz="3000" b="1">
                 <a:solidFill>
                   <a:srgbClr val="233A70"/>
@@ -16673,6 +16929,7 @@
           <a:lstStyle xmlns:a="http://schemas.openxmlformats.org/drawingml/2006/main"/>
           <a:p xmlns:a="http://schemas.openxmlformats.org/drawingml/2006/main">
             <a:pPr algn="ctr">
+              <a:buNone/>
               <a:defRPr sz="3000" b="1">
                 <a:solidFill>
                   <a:srgbClr val="233A70"/>
@@ -16764,6 +17021,7 @@
           <a:lstStyle xmlns:a="http://schemas.openxmlformats.org/drawingml/2006/main"/>
           <a:p xmlns:a="http://schemas.openxmlformats.org/drawingml/2006/main">
             <a:pPr algn="ctr">
+              <a:buNone/>
               <a:defRPr sz="1350" b="1">
                 <a:solidFill>
                   <a:srgbClr val="14B978"/>
@@ -16822,6 +17080,7 @@
           <a:lstStyle xmlns:a="http://schemas.openxmlformats.org/drawingml/2006/main"/>
           <a:p xmlns:a="http://schemas.openxmlformats.org/drawingml/2006/main">
             <a:pPr algn="ctr">
+              <a:buNone/>
               <a:defRPr sz="1425" b="0">
                 <a:solidFill>
                   <a:srgbClr val="FFFFFF"/>
@@ -16940,6 +17199,7 @@
           <a:lstStyle xmlns:a="http://schemas.openxmlformats.org/drawingml/2006/main"/>
           <a:p xmlns:a="http://schemas.openxmlformats.org/drawingml/2006/main">
             <a:pPr algn="l">
+              <a:buNone/>
               <a:defRPr sz="3600" b="1">
                 <a:solidFill>
                   <a:srgbClr val="233A70"/>
@@ -17029,6 +17289,7 @@
           <a:lstStyle xmlns:a="http://schemas.openxmlformats.org/drawingml/2006/main"/>
           <a:p xmlns:a="http://schemas.openxmlformats.org/drawingml/2006/main">
             <a:pPr algn="l">
+              <a:buNone/>
               <a:defRPr sz="1050" b="0">
                 <a:solidFill>
                   <a:srgbClr val="5B6577"/>
@@ -17087,6 +17348,7 @@
           <a:lstStyle xmlns:a="http://schemas.openxmlformats.org/drawingml/2006/main"/>
           <a:p xmlns:a="http://schemas.openxmlformats.org/drawingml/2006/main">
             <a:pPr algn="r">
+              <a:buNone/>
               <a:defRPr sz="1050" b="0">
                 <a:solidFill>
                   <a:srgbClr val="5B6577"/>
@@ -17145,6 +17407,7 @@
           <a:lstStyle xmlns:a="http://schemas.openxmlformats.org/drawingml/2006/main"/>
           <a:p xmlns:a="http://schemas.openxmlformats.org/drawingml/2006/main">
             <a:pPr algn="ctr">
+              <a:buNone/>
               <a:defRPr sz="3225" b="1">
                 <a:solidFill>
                   <a:srgbClr val="233A70"/>
@@ -17236,6 +17499,7 @@
           <a:lstStyle xmlns:a="http://schemas.openxmlformats.org/drawingml/2006/main"/>
           <a:p xmlns:a="http://schemas.openxmlformats.org/drawingml/2006/main">
             <a:pPr algn="ctr">
+              <a:buNone/>
               <a:defRPr sz="3150" b="1">
                 <a:solidFill>
                   <a:srgbClr val="BE3C37"/>
@@ -17294,6 +17558,7 @@
           <a:lstStyle xmlns:a="http://schemas.openxmlformats.org/drawingml/2006/main"/>
           <a:p xmlns:a="http://schemas.openxmlformats.org/drawingml/2006/main">
             <a:pPr algn="ctr">
+              <a:buNone/>
               <a:defRPr sz="1575" b="1">
                 <a:solidFill>
                   <a:srgbClr val="172033"/>
@@ -17385,6 +17650,7 @@
           <a:lstStyle xmlns:a="http://schemas.openxmlformats.org/drawingml/2006/main"/>
           <a:p xmlns:a="http://schemas.openxmlformats.org/drawingml/2006/main">
             <a:pPr algn="ctr">
+              <a:buNone/>
               <a:defRPr sz="3150" b="1">
                 <a:solidFill>
                   <a:srgbClr val="087A50"/>
@@ -17443,6 +17709,7 @@
           <a:lstStyle xmlns:a="http://schemas.openxmlformats.org/drawingml/2006/main"/>
           <a:p xmlns:a="http://schemas.openxmlformats.org/drawingml/2006/main">
             <a:pPr algn="ctr">
+              <a:buNone/>
               <a:defRPr sz="1575" b="1">
                 <a:solidFill>
                   <a:srgbClr val="172033"/>
@@ -17534,6 +17801,7 @@
           <a:lstStyle xmlns:a="http://schemas.openxmlformats.org/drawingml/2006/main"/>
           <a:p xmlns:a="http://schemas.openxmlformats.org/drawingml/2006/main">
             <a:pPr algn="ctr">
+              <a:buNone/>
               <a:defRPr sz="3150" b="1">
                 <a:solidFill>
                   <a:srgbClr val="C89B14"/>
@@ -17592,6 +17860,7 @@
           <a:lstStyle xmlns:a="http://schemas.openxmlformats.org/drawingml/2006/main"/>
           <a:p xmlns:a="http://schemas.openxmlformats.org/drawingml/2006/main">
             <a:pPr algn="ctr">
+              <a:buNone/>
               <a:defRPr sz="1575" b="1">
                 <a:solidFill>
                   <a:srgbClr val="172033"/>
@@ -17683,6 +17952,7 @@
           <a:lstStyle xmlns:a="http://schemas.openxmlformats.org/drawingml/2006/main"/>
           <a:p xmlns:a="http://schemas.openxmlformats.org/drawingml/2006/main">
             <a:pPr algn="ctr">
+              <a:buNone/>
               <a:defRPr sz="2850" b="1">
                 <a:solidFill>
                   <a:srgbClr val="233A70"/>
@@ -17741,6 +18011,7 @@
           <a:lstStyle xmlns:a="http://schemas.openxmlformats.org/drawingml/2006/main"/>
           <a:p xmlns:a="http://schemas.openxmlformats.org/drawingml/2006/main">
             <a:pPr algn="ctr">
+              <a:buNone/>
               <a:defRPr sz="1575" b="0">
                 <a:solidFill>
                   <a:srgbClr val="5B6577"/>
@@ -17832,6 +18103,7 @@
           <a:lstStyle xmlns:a="http://schemas.openxmlformats.org/drawingml/2006/main"/>
           <a:p xmlns:a="http://schemas.openxmlformats.org/drawingml/2006/main">
             <a:pPr algn="ctr">
+              <a:buNone/>
               <a:defRPr sz="3450" b="1">
                 <a:solidFill>
                   <a:srgbClr val="FFFFFF"/>
@@ -17890,6 +18162,7 @@
           <a:lstStyle xmlns:a="http://schemas.openxmlformats.org/drawingml/2006/main"/>
           <a:p xmlns:a="http://schemas.openxmlformats.org/drawingml/2006/main">
             <a:pPr algn="ctr">
+              <a:buNone/>
               <a:defRPr sz="1650" b="1">
                 <a:solidFill>
                   <a:srgbClr val="14B978"/>
@@ -17948,6 +18221,7 @@
           <a:lstStyle xmlns:a="http://schemas.openxmlformats.org/drawingml/2006/main"/>
           <a:p xmlns:a="http://schemas.openxmlformats.org/drawingml/2006/main">
             <a:pPr algn="ctr">
+              <a:buNone/>
               <a:defRPr sz="1500" b="1">
                 <a:solidFill>
                   <a:srgbClr val="5B6577"/>
@@ -18006,6 +18280,7 @@
           <a:lstStyle xmlns:a="http://schemas.openxmlformats.org/drawingml/2006/main"/>
           <a:p xmlns:a="http://schemas.openxmlformats.org/drawingml/2006/main">
             <a:pPr algn="ctr">
+              <a:buNone/>
               <a:defRPr sz="1350" b="0">
                 <a:solidFill>
                   <a:srgbClr val="5B6577"/>
@@ -18124,6 +18399,7 @@
           <a:lstStyle xmlns:a="http://schemas.openxmlformats.org/drawingml/2006/main"/>
           <a:p xmlns:a="http://schemas.openxmlformats.org/drawingml/2006/main">
             <a:pPr algn="l">
+              <a:buNone/>
               <a:defRPr sz="3600" b="1">
                 <a:solidFill>
                   <a:srgbClr val="233A70"/>
@@ -18213,6 +18489,7 @@
           <a:lstStyle xmlns:a="http://schemas.openxmlformats.org/drawingml/2006/main"/>
           <a:p xmlns:a="http://schemas.openxmlformats.org/drawingml/2006/main">
             <a:pPr algn="l">
+              <a:buNone/>
               <a:defRPr sz="1050" b="0">
                 <a:solidFill>
                   <a:srgbClr val="5B6577"/>
@@ -18271,6 +18548,7 @@
           <a:lstStyle xmlns:a="http://schemas.openxmlformats.org/drawingml/2006/main"/>
           <a:p xmlns:a="http://schemas.openxmlformats.org/drawingml/2006/main">
             <a:pPr algn="r">
+              <a:buNone/>
               <a:defRPr sz="1050" b="0">
                 <a:solidFill>
                   <a:srgbClr val="5B6577"/>
@@ -18362,6 +18640,7 @@
           <a:lstStyle xmlns:a="http://schemas.openxmlformats.org/drawingml/2006/main"/>
           <a:p xmlns:a="http://schemas.openxmlformats.org/drawingml/2006/main">
             <a:pPr algn="l">
+              <a:buNone/>
               <a:defRPr sz="1350" b="1">
                 <a:solidFill>
                   <a:srgbClr val="233A70"/>
@@ -18420,6 +18699,7 @@
           <a:lstStyle xmlns:a="http://schemas.openxmlformats.org/drawingml/2006/main"/>
           <a:p xmlns:a="http://schemas.openxmlformats.org/drawingml/2006/main">
             <a:pPr algn="l">
+              <a:buNone/>
               <a:defRPr sz="2250" b="1">
                 <a:solidFill>
                   <a:srgbClr val="172033"/>
@@ -18443,6 +18723,7 @@
           </a:p>
           <a:p xmlns:a="http://schemas.openxmlformats.org/drawingml/2006/main">
             <a:pPr algn="l">
+              <a:buNone/>
               <a:defRPr sz="2250" b="1">
                 <a:solidFill>
                   <a:srgbClr val="172033"/>
@@ -18466,6 +18747,7 @@
           </a:p>
           <a:p xmlns:a="http://schemas.openxmlformats.org/drawingml/2006/main">
             <a:pPr algn="l">
+              <a:buNone/>
               <a:defRPr sz="2250" b="1">
                 <a:solidFill>
                   <a:srgbClr val="172033"/>
@@ -18524,6 +18806,7 @@
           <a:lstStyle xmlns:a="http://schemas.openxmlformats.org/drawingml/2006/main"/>
           <a:p xmlns:a="http://schemas.openxmlformats.org/drawingml/2006/main">
             <a:pPr algn="l">
+              <a:buNone/>
               <a:defRPr sz="1350" b="0">
                 <a:solidFill>
                   <a:srgbClr val="5B6577"/>
@@ -18617,6 +18900,7 @@
           <a:lstStyle xmlns:a="http://schemas.openxmlformats.org/drawingml/2006/main"/>
           <a:p xmlns:a="http://schemas.openxmlformats.org/drawingml/2006/main">
             <a:pPr algn="l">
+              <a:buNone/>
               <a:defRPr sz="1350" b="1">
                 <a:solidFill>
                   <a:srgbClr val="233A70"/>
@@ -18675,6 +18959,7 @@
           <a:lstStyle xmlns:a="http://schemas.openxmlformats.org/drawingml/2006/main"/>
           <a:p xmlns:a="http://schemas.openxmlformats.org/drawingml/2006/main">
             <a:pPr algn="l">
+              <a:buNone/>
               <a:defRPr sz="1725" b="1">
                 <a:solidFill>
                   <a:srgbClr val="172033"/>
@@ -18698,6 +18983,7 @@
           </a:p>
           <a:p xmlns:a="http://schemas.openxmlformats.org/drawingml/2006/main">
             <a:pPr algn="l">
+              <a:buNone/>
               <a:defRPr sz="1725" b="1">
                 <a:solidFill>
                   <a:srgbClr val="172033"/>
@@ -18721,6 +19007,7 @@
           </a:p>
           <a:p xmlns:a="http://schemas.openxmlformats.org/drawingml/2006/main">
             <a:pPr algn="l">
+              <a:buNone/>
               <a:defRPr sz="1725" b="1">
                 <a:solidFill>
                   <a:srgbClr val="172033"/>
@@ -18744,6 +19031,7 @@
           </a:p>
           <a:p xmlns:a="http://schemas.openxmlformats.org/drawingml/2006/main">
             <a:pPr algn="l">
+              <a:buNone/>
               <a:defRPr sz="1725" b="1">
                 <a:solidFill>
                   <a:srgbClr val="172033"/>
@@ -18802,6 +19090,7 @@
           <a:lstStyle xmlns:a="http://schemas.openxmlformats.org/drawingml/2006/main"/>
           <a:p xmlns:a="http://schemas.openxmlformats.org/drawingml/2006/main">
             <a:pPr algn="l">
+              <a:buNone/>
               <a:defRPr sz="1350" b="0">
                 <a:solidFill>
                   <a:srgbClr val="5B6577"/>
@@ -18860,6 +19149,7 @@
           <a:lstStyle xmlns:a="http://schemas.openxmlformats.org/drawingml/2006/main"/>
           <a:p xmlns:a="http://schemas.openxmlformats.org/drawingml/2006/main">
             <a:pPr algn="ctr">
+              <a:buNone/>
               <a:defRPr sz="1275" b="1">
                 <a:solidFill>
                   <a:srgbClr val="233A70"/>
@@ -18951,6 +19241,7 @@
           <a:lstStyle xmlns:a="http://schemas.openxmlformats.org/drawingml/2006/main"/>
           <a:p xmlns:a="http://schemas.openxmlformats.org/drawingml/2006/main">
             <a:pPr algn="ctr">
+              <a:buNone/>
               <a:defRPr sz="1350" b="1">
                 <a:solidFill>
                   <a:srgbClr val="BE3C37"/>
@@ -19009,6 +19300,7 @@
           <a:lstStyle xmlns:a="http://schemas.openxmlformats.org/drawingml/2006/main"/>
           <a:p xmlns:a="http://schemas.openxmlformats.org/drawingml/2006/main">
             <a:pPr algn="ctr">
+              <a:buNone/>
               <a:defRPr sz="1350" b="0">
                 <a:solidFill>
                   <a:srgbClr val="172033"/>
@@ -19100,6 +19392,7 @@
           <a:lstStyle xmlns:a="http://schemas.openxmlformats.org/drawingml/2006/main"/>
           <a:p xmlns:a="http://schemas.openxmlformats.org/drawingml/2006/main">
             <a:pPr algn="ctr">
+              <a:buNone/>
               <a:defRPr sz="1350" b="1">
                 <a:solidFill>
                   <a:srgbClr val="C89B14"/>
@@ -19158,6 +19451,7 @@
           <a:lstStyle xmlns:a="http://schemas.openxmlformats.org/drawingml/2006/main"/>
           <a:p xmlns:a="http://schemas.openxmlformats.org/drawingml/2006/main">
             <a:pPr algn="ctr">
+              <a:buNone/>
               <a:defRPr sz="1350" b="0">
                 <a:solidFill>
                   <a:srgbClr val="172033"/>
@@ -19249,6 +19543,7 @@
           <a:lstStyle xmlns:a="http://schemas.openxmlformats.org/drawingml/2006/main"/>
           <a:p xmlns:a="http://schemas.openxmlformats.org/drawingml/2006/main">
             <a:pPr algn="ctr">
+              <a:buNone/>
               <a:defRPr sz="1350" b="1">
                 <a:solidFill>
                   <a:srgbClr val="087A50"/>
@@ -19307,6 +19602,7 @@
           <a:lstStyle xmlns:a="http://schemas.openxmlformats.org/drawingml/2006/main"/>
           <a:p xmlns:a="http://schemas.openxmlformats.org/drawingml/2006/main">
             <a:pPr algn="ctr">
+              <a:buNone/>
               <a:defRPr sz="1350" b="0">
                 <a:solidFill>
                   <a:srgbClr val="172033"/>
@@ -19425,6 +19721,7 @@
           <a:lstStyle xmlns:a="http://schemas.openxmlformats.org/drawingml/2006/main"/>
           <a:p xmlns:a="http://schemas.openxmlformats.org/drawingml/2006/main">
             <a:pPr algn="l">
+              <a:buNone/>
               <a:defRPr sz="3600" b="1">
                 <a:solidFill>
                   <a:srgbClr val="233A70"/>
@@ -19514,6 +19811,7 @@
           <a:lstStyle xmlns:a="http://schemas.openxmlformats.org/drawingml/2006/main"/>
           <a:p xmlns:a="http://schemas.openxmlformats.org/drawingml/2006/main">
             <a:pPr algn="l">
+              <a:buNone/>
               <a:defRPr sz="1050" b="0">
                 <a:solidFill>
                   <a:srgbClr val="5B6577"/>
@@ -19572,6 +19870,7 @@
           <a:lstStyle xmlns:a="http://schemas.openxmlformats.org/drawingml/2006/main"/>
           <a:p xmlns:a="http://schemas.openxmlformats.org/drawingml/2006/main">
             <a:pPr algn="r">
+              <a:buNone/>
               <a:defRPr sz="1050" b="0">
                 <a:solidFill>
                   <a:srgbClr val="5B6577"/>
@@ -19696,6 +19995,7 @@
           <a:lstStyle xmlns:a="http://schemas.openxmlformats.org/drawingml/2006/main"/>
           <a:p xmlns:a="http://schemas.openxmlformats.org/drawingml/2006/main">
             <a:pPr algn="ctr">
+              <a:buNone/>
               <a:defRPr sz="1650" b="1">
                 <a:solidFill>
                   <a:srgbClr val="233A70"/>
@@ -19754,6 +20054,7 @@
           <a:lstStyle xmlns:a="http://schemas.openxmlformats.org/drawingml/2006/main"/>
           <a:p xmlns:a="http://schemas.openxmlformats.org/drawingml/2006/main">
             <a:pPr algn="ctr">
+              <a:buNone/>
               <a:defRPr sz="1350" b="0">
                 <a:solidFill>
                   <a:srgbClr val="5B6577"/>
@@ -19847,6 +20148,7 @@
           <a:lstStyle xmlns:a="http://schemas.openxmlformats.org/drawingml/2006/main"/>
           <a:p xmlns:a="http://schemas.openxmlformats.org/drawingml/2006/main">
             <a:pPr algn="ctr">
+              <a:buNone/>
               <a:defRPr sz="1650" b="1">
                 <a:solidFill>
                   <a:srgbClr val="233A70"/>
@@ -19905,6 +20207,7 @@
           <a:lstStyle xmlns:a="http://schemas.openxmlformats.org/drawingml/2006/main"/>
           <a:p xmlns:a="http://schemas.openxmlformats.org/drawingml/2006/main">
             <a:pPr algn="ctr">
+              <a:buNone/>
               <a:defRPr sz="1350" b="0">
                 <a:solidFill>
                   <a:srgbClr val="5B6577"/>
@@ -19998,6 +20301,7 @@
           <a:lstStyle xmlns:a="http://schemas.openxmlformats.org/drawingml/2006/main"/>
           <a:p xmlns:a="http://schemas.openxmlformats.org/drawingml/2006/main">
             <a:pPr algn="ctr">
+              <a:buNone/>
               <a:defRPr sz="1650" b="1">
                 <a:solidFill>
                   <a:srgbClr val="233A70"/>
@@ -20056,6 +20360,7 @@
           <a:lstStyle xmlns:a="http://schemas.openxmlformats.org/drawingml/2006/main"/>
           <a:p xmlns:a="http://schemas.openxmlformats.org/drawingml/2006/main">
             <a:pPr algn="ctr">
+              <a:buNone/>
               <a:defRPr sz="1350" b="0">
                 <a:solidFill>
                   <a:srgbClr val="5B6577"/>
@@ -20114,6 +20419,7 @@
           <a:lstStyle xmlns:a="http://schemas.openxmlformats.org/drawingml/2006/main"/>
           <a:p xmlns:a="http://schemas.openxmlformats.org/drawingml/2006/main">
             <a:pPr algn="ctr">
+              <a:buNone/>
               <a:defRPr sz="3450" b="1">
                 <a:solidFill>
                   <a:srgbClr val="233A70"/>
@@ -20172,6 +20478,7 @@
           <a:lstStyle xmlns:a="http://schemas.openxmlformats.org/drawingml/2006/main"/>
           <a:p xmlns:a="http://schemas.openxmlformats.org/drawingml/2006/main">
             <a:pPr algn="ctr">
+              <a:buNone/>
               <a:defRPr sz="3450" b="1">
                 <a:solidFill>
                   <a:srgbClr val="233A70"/>
@@ -20230,6 +20537,7 @@
           <a:lstStyle xmlns:a="http://schemas.openxmlformats.org/drawingml/2006/main"/>
           <a:p xmlns:a="http://schemas.openxmlformats.org/drawingml/2006/main">
             <a:pPr algn="ctr">
+              <a:buNone/>
               <a:defRPr sz="1425" b="1">
                 <a:solidFill>
                   <a:srgbClr val="BE3C37"/>
@@ -20288,6 +20596,7 @@
           <a:lstStyle xmlns:a="http://schemas.openxmlformats.org/drawingml/2006/main"/>
           <a:p xmlns:a="http://schemas.openxmlformats.org/drawingml/2006/main">
             <a:pPr algn="ctr">
+              <a:buNone/>
               <a:defRPr sz="4050" b="1">
                 <a:solidFill>
                   <a:srgbClr val="BE3C37"/>
@@ -20346,6 +20655,7 @@
           <a:lstStyle xmlns:a="http://schemas.openxmlformats.org/drawingml/2006/main"/>
           <a:p xmlns:a="http://schemas.openxmlformats.org/drawingml/2006/main">
             <a:pPr algn="ctr">
+              <a:buNone/>
               <a:defRPr sz="1800" b="1">
                 <a:solidFill>
                   <a:srgbClr val="172033"/>
@@ -20435,6 +20745,7 @@
           <a:lstStyle xmlns:a="http://schemas.openxmlformats.org/drawingml/2006/main"/>
           <a:p xmlns:a="http://schemas.openxmlformats.org/drawingml/2006/main">
             <a:pPr algn="ctr">
+              <a:buNone/>
               <a:defRPr sz="1425" b="1">
                 <a:solidFill>
                   <a:srgbClr val="C89B14"/>
@@ -20493,6 +20804,7 @@
           <a:lstStyle xmlns:a="http://schemas.openxmlformats.org/drawingml/2006/main"/>
           <a:p xmlns:a="http://schemas.openxmlformats.org/drawingml/2006/main">
             <a:pPr algn="ctr">
+              <a:buNone/>
               <a:defRPr sz="4050" b="1">
                 <a:solidFill>
                   <a:srgbClr val="C89B14"/>
@@ -20551,6 +20863,7 @@
           <a:lstStyle xmlns:a="http://schemas.openxmlformats.org/drawingml/2006/main"/>
           <a:p xmlns:a="http://schemas.openxmlformats.org/drawingml/2006/main">
             <a:pPr algn="ctr">
+              <a:buNone/>
               <a:defRPr sz="1800" b="1">
                 <a:solidFill>
                   <a:srgbClr val="172033"/>
@@ -20642,6 +20955,7 @@
           <a:lstStyle xmlns:a="http://schemas.openxmlformats.org/drawingml/2006/main"/>
           <a:p xmlns:a="http://schemas.openxmlformats.org/drawingml/2006/main">
             <a:pPr algn="ctr">
+              <a:buNone/>
               <a:defRPr sz="1350" b="1">
                 <a:solidFill>
                   <a:srgbClr val="087A50"/>
@@ -20760,6 +21074,7 @@
           <a:lstStyle xmlns:a="http://schemas.openxmlformats.org/drawingml/2006/main"/>
           <a:p xmlns:a="http://schemas.openxmlformats.org/drawingml/2006/main">
             <a:pPr algn="l">
+              <a:buNone/>
               <a:defRPr sz="3600" b="1">
                 <a:solidFill>
                   <a:srgbClr val="233A70"/>
@@ -20849,6 +21164,7 @@
           <a:lstStyle xmlns:a="http://schemas.openxmlformats.org/drawingml/2006/main"/>
           <a:p xmlns:a="http://schemas.openxmlformats.org/drawingml/2006/main">
             <a:pPr algn="l">
+              <a:buNone/>
               <a:defRPr sz="1050" b="0">
                 <a:solidFill>
                   <a:srgbClr val="5B6577"/>
@@ -20907,6 +21223,7 @@
           <a:lstStyle xmlns:a="http://schemas.openxmlformats.org/drawingml/2006/main"/>
           <a:p xmlns:a="http://schemas.openxmlformats.org/drawingml/2006/main">
             <a:pPr algn="r">
+              <a:buNone/>
               <a:defRPr sz="1050" b="0">
                 <a:solidFill>
                   <a:srgbClr val="5B6577"/>
@@ -20965,6 +21282,7 @@
           <a:lstStyle xmlns:a="http://schemas.openxmlformats.org/drawingml/2006/main"/>
           <a:p xmlns:a="http://schemas.openxmlformats.org/drawingml/2006/main">
             <a:pPr algn="ctr">
+              <a:buNone/>
               <a:defRPr sz="1350" b="0">
                 <a:solidFill>
                   <a:srgbClr val="5B6577"/>
@@ -21058,6 +21376,7 @@
           <a:lstStyle xmlns:a="http://schemas.openxmlformats.org/drawingml/2006/main"/>
           <a:p xmlns:a="http://schemas.openxmlformats.org/drawingml/2006/main">
             <a:pPr algn="ctr">
+              <a:buNone/>
               <a:defRPr sz="1725" b="1">
                 <a:solidFill>
                   <a:srgbClr val="233A70"/>
@@ -21116,6 +21435,7 @@
           <a:lstStyle xmlns:a="http://schemas.openxmlformats.org/drawingml/2006/main"/>
           <a:p xmlns:a="http://schemas.openxmlformats.org/drawingml/2006/main">
             <a:pPr algn="ctr">
+              <a:buNone/>
               <a:defRPr sz="1200" b="1">
                 <a:solidFill>
                   <a:srgbClr val="5B6577"/>
@@ -21174,6 +21494,7 @@
           <a:lstStyle xmlns:a="http://schemas.openxmlformats.org/drawingml/2006/main"/>
           <a:p xmlns:a="http://schemas.openxmlformats.org/drawingml/2006/main">
             <a:pPr algn="ctr">
+              <a:buNone/>
               <a:defRPr sz="3150" b="1">
                 <a:solidFill>
                   <a:srgbClr val="233A70"/>
@@ -21232,6 +21553,7 @@
           <a:lstStyle xmlns:a="http://schemas.openxmlformats.org/drawingml/2006/main"/>
           <a:p xmlns:a="http://schemas.openxmlformats.org/drawingml/2006/main">
             <a:pPr algn="ctr">
+              <a:buNone/>
               <a:defRPr sz="2850" b="1">
                 <a:solidFill>
                   <a:srgbClr val="BE3C37"/>
@@ -21290,6 +21612,7 @@
           <a:lstStyle xmlns:a="http://schemas.openxmlformats.org/drawingml/2006/main"/>
           <a:p xmlns:a="http://schemas.openxmlformats.org/drawingml/2006/main">
             <a:pPr algn="ctr">
+              <a:buNone/>
               <a:defRPr sz="1275" b="1">
                 <a:solidFill>
                   <a:srgbClr val="BE3C37"/>
@@ -21348,6 +21671,7 @@
           <a:lstStyle xmlns:a="http://schemas.openxmlformats.org/drawingml/2006/main"/>
           <a:p xmlns:a="http://schemas.openxmlformats.org/drawingml/2006/main">
             <a:pPr algn="ctr">
+              <a:buNone/>
               <a:defRPr sz="3225" b="1">
                 <a:solidFill>
                   <a:srgbClr val="BE3C37"/>
@@ -21439,6 +21763,7 @@
           <a:lstStyle xmlns:a="http://schemas.openxmlformats.org/drawingml/2006/main"/>
           <a:p xmlns:a="http://schemas.openxmlformats.org/drawingml/2006/main">
             <a:pPr algn="ctr">
+              <a:buNone/>
               <a:defRPr sz="1350" b="1">
                 <a:solidFill>
                   <a:srgbClr val="BE3C37"/>
@@ -21532,6 +21857,7 @@
           <a:lstStyle xmlns:a="http://schemas.openxmlformats.org/drawingml/2006/main"/>
           <a:p xmlns:a="http://schemas.openxmlformats.org/drawingml/2006/main">
             <a:pPr algn="ctr">
+              <a:buNone/>
               <a:defRPr sz="1725" b="1">
                 <a:solidFill>
                   <a:srgbClr val="233A70"/>
@@ -21590,6 +21916,7 @@
           <a:lstStyle xmlns:a="http://schemas.openxmlformats.org/drawingml/2006/main"/>
           <a:p xmlns:a="http://schemas.openxmlformats.org/drawingml/2006/main">
             <a:pPr algn="ctr">
+              <a:buNone/>
               <a:defRPr sz="1200" b="1">
                 <a:solidFill>
                   <a:srgbClr val="5B6577"/>
@@ -21648,6 +21975,7 @@
           <a:lstStyle xmlns:a="http://schemas.openxmlformats.org/drawingml/2006/main"/>
           <a:p xmlns:a="http://schemas.openxmlformats.org/drawingml/2006/main">
             <a:pPr algn="ctr">
+              <a:buNone/>
               <a:defRPr sz="3150" b="1">
                 <a:solidFill>
                   <a:srgbClr val="233A70"/>
@@ -21706,6 +22034,7 @@
           <a:lstStyle xmlns:a="http://schemas.openxmlformats.org/drawingml/2006/main"/>
           <a:p xmlns:a="http://schemas.openxmlformats.org/drawingml/2006/main">
             <a:pPr algn="ctr">
+              <a:buNone/>
               <a:defRPr sz="2850" b="1">
                 <a:solidFill>
                   <a:srgbClr val="C89B14"/>
@@ -21764,6 +22093,7 @@
           <a:lstStyle xmlns:a="http://schemas.openxmlformats.org/drawingml/2006/main"/>
           <a:p xmlns:a="http://schemas.openxmlformats.org/drawingml/2006/main">
             <a:pPr algn="ctr">
+              <a:buNone/>
               <a:defRPr sz="1275" b="1">
                 <a:solidFill>
                   <a:srgbClr val="C89B14"/>
@@ -21822,6 +22152,7 @@
           <a:lstStyle xmlns:a="http://schemas.openxmlformats.org/drawingml/2006/main"/>
           <a:p xmlns:a="http://schemas.openxmlformats.org/drawingml/2006/main">
             <a:pPr algn="ctr">
+              <a:buNone/>
               <a:defRPr sz="3225" b="1">
                 <a:solidFill>
                   <a:srgbClr val="C89B14"/>
@@ -21913,6 +22244,7 @@
           <a:lstStyle xmlns:a="http://schemas.openxmlformats.org/drawingml/2006/main"/>
           <a:p xmlns:a="http://schemas.openxmlformats.org/drawingml/2006/main">
             <a:pPr algn="ctr">
+              <a:buNone/>
               <a:defRPr sz="1350" b="1">
                 <a:solidFill>
                   <a:srgbClr val="C89B14"/>
@@ -22006,6 +22338,7 @@
           <a:lstStyle xmlns:a="http://schemas.openxmlformats.org/drawingml/2006/main"/>
           <a:p xmlns:a="http://schemas.openxmlformats.org/drawingml/2006/main">
             <a:pPr algn="ctr">
+              <a:buNone/>
               <a:defRPr sz="1725" b="1">
                 <a:solidFill>
                   <a:srgbClr val="233A70"/>
@@ -22064,6 +22397,7 @@
           <a:lstStyle xmlns:a="http://schemas.openxmlformats.org/drawingml/2006/main"/>
           <a:p xmlns:a="http://schemas.openxmlformats.org/drawingml/2006/main">
             <a:pPr algn="ctr">
+              <a:buNone/>
               <a:defRPr sz="1200" b="1">
                 <a:solidFill>
                   <a:srgbClr val="5B6577"/>
@@ -22122,6 +22456,7 @@
           <a:lstStyle xmlns:a="http://schemas.openxmlformats.org/drawingml/2006/main"/>
           <a:p xmlns:a="http://schemas.openxmlformats.org/drawingml/2006/main">
             <a:pPr algn="ctr">
+              <a:buNone/>
               <a:defRPr sz="3150" b="1">
                 <a:solidFill>
                   <a:srgbClr val="233A70"/>
@@ -22180,6 +22515,7 @@
           <a:lstStyle xmlns:a="http://schemas.openxmlformats.org/drawingml/2006/main"/>
           <a:p xmlns:a="http://schemas.openxmlformats.org/drawingml/2006/main">
             <a:pPr algn="ctr">
+              <a:buNone/>
               <a:defRPr sz="2850" b="1">
                 <a:solidFill>
                   <a:srgbClr val="C89B14"/>
@@ -22238,6 +22574,7 @@
           <a:lstStyle xmlns:a="http://schemas.openxmlformats.org/drawingml/2006/main"/>
           <a:p xmlns:a="http://schemas.openxmlformats.org/drawingml/2006/main">
             <a:pPr algn="ctr">
+              <a:buNone/>
               <a:defRPr sz="1275" b="1">
                 <a:solidFill>
                   <a:srgbClr val="C89B14"/>
@@ -22296,6 +22633,7 @@
           <a:lstStyle xmlns:a="http://schemas.openxmlformats.org/drawingml/2006/main"/>
           <a:p xmlns:a="http://schemas.openxmlformats.org/drawingml/2006/main">
             <a:pPr algn="ctr">
+              <a:buNone/>
               <a:defRPr sz="3225" b="1">
                 <a:solidFill>
                   <a:srgbClr val="C89B14"/>
@@ -22387,6 +22725,7 @@
           <a:lstStyle xmlns:a="http://schemas.openxmlformats.org/drawingml/2006/main"/>
           <a:p xmlns:a="http://schemas.openxmlformats.org/drawingml/2006/main">
             <a:pPr algn="ctr">
+              <a:buNone/>
               <a:defRPr sz="1350" b="1">
                 <a:solidFill>
                   <a:srgbClr val="C89B14"/>
@@ -22445,6 +22784,7 @@
           <a:lstStyle xmlns:a="http://schemas.openxmlformats.org/drawingml/2006/main"/>
           <a:p xmlns:a="http://schemas.openxmlformats.org/drawingml/2006/main">
             <a:pPr algn="ctr">
+              <a:buNone/>
               <a:defRPr sz="1500" b="1">
                 <a:solidFill>
                   <a:srgbClr val="233A70"/>
@@ -22563,6 +22903,7 @@
           <a:lstStyle xmlns:a="http://schemas.openxmlformats.org/drawingml/2006/main"/>
           <a:p xmlns:a="http://schemas.openxmlformats.org/drawingml/2006/main">
             <a:pPr algn="l">
+              <a:buNone/>
               <a:defRPr sz="3600" b="1">
                 <a:solidFill>
                   <a:srgbClr val="233A70"/>
@@ -22652,6 +22993,7 @@
           <a:lstStyle xmlns:a="http://schemas.openxmlformats.org/drawingml/2006/main"/>
           <a:p xmlns:a="http://schemas.openxmlformats.org/drawingml/2006/main">
             <a:pPr algn="l">
+              <a:buNone/>
               <a:defRPr sz="1050" b="0">
                 <a:solidFill>
                   <a:srgbClr val="5B6577"/>
@@ -22710,6 +23052,7 @@
           <a:lstStyle xmlns:a="http://schemas.openxmlformats.org/drawingml/2006/main"/>
           <a:p xmlns:a="http://schemas.openxmlformats.org/drawingml/2006/main">
             <a:pPr algn="r">
+              <a:buNone/>
               <a:defRPr sz="1050" b="0">
                 <a:solidFill>
                   <a:srgbClr val="5B6577"/>
@@ -22735,14 +23078,14 @@
       </p:sp>
       <p:pic>
         <p:nvPicPr>
-          <p:cNvPr id="15" name=""/>
+          <p:cNvPr id="17" name=""/>
           <p:cNvPicPr>
             <a:picLocks xmlns:a="http://schemas.openxmlformats.org/drawingml/2006/main" noChangeAspect="1"/>
           </p:cNvPicPr>
           <p:nvPr/>
         </p:nvPicPr>
         <p:blipFill>
-          <a:blip xmlns:r="http://schemas.openxmlformats.org/officeDocument/2006/relationships" xmlns:a="http://schemas.openxmlformats.org/drawingml/2006/main" r:embed="R9950a1e10b574ee8"/>
+          <a:blip xmlns:r="http://schemas.openxmlformats.org/officeDocument/2006/relationships" xmlns:a="http://schemas.openxmlformats.org/drawingml/2006/main" r:embed="Rc9e1f603bc5946b5"/>
           <a:stretch xmlns:a="http://schemas.openxmlformats.org/drawingml/2006/main"/>
         </p:blipFill>
         <p:spPr>
@@ -22823,6 +23166,7 @@
           <a:lstStyle xmlns:a="http://schemas.openxmlformats.org/drawingml/2006/main"/>
           <a:p xmlns:a="http://schemas.openxmlformats.org/drawingml/2006/main">
             <a:pPr algn="ctr">
+              <a:buNone/>
               <a:defRPr sz="1575" b="1">
                 <a:solidFill>
                   <a:srgbClr val="BE3C37"/>
@@ -22881,6 +23225,7 @@
           <a:lstStyle xmlns:a="http://schemas.openxmlformats.org/drawingml/2006/main"/>
           <a:p xmlns:a="http://schemas.openxmlformats.org/drawingml/2006/main">
             <a:pPr algn="ctr">
+              <a:buNone/>
               <a:defRPr sz="1275" b="1">
                 <a:solidFill>
                   <a:srgbClr val="233A70"/>
@@ -22899,7 +23244,7 @@
                 <a:ea typeface="Arial"/>
                 <a:cs typeface="Arial"/>
               </a:rPr>
-              <a:t>Empirical transfer from EfficientNet-B0 artifacts—not direct attacks on proprietary models.</a:t>
+              <a:t>Transfer from EfficientNet-B0 artifacts—not direct attacks · Source: FAIRLab manuscript</a:t>
             </a:r>
           </a:p>
         </p:txBody>
@@ -22999,6 +23344,7 @@
           <a:lstStyle xmlns:a="http://schemas.openxmlformats.org/drawingml/2006/main"/>
           <a:p xmlns:a="http://schemas.openxmlformats.org/drawingml/2006/main">
             <a:pPr algn="l">
+              <a:buNone/>
               <a:defRPr sz="3600" b="1">
                 <a:solidFill>
                   <a:srgbClr val="233A70"/>
@@ -23088,6 +23434,7 @@
           <a:lstStyle xmlns:a="http://schemas.openxmlformats.org/drawingml/2006/main"/>
           <a:p xmlns:a="http://schemas.openxmlformats.org/drawingml/2006/main">
             <a:pPr algn="l">
+              <a:buNone/>
               <a:defRPr sz="1050" b="0">
                 <a:solidFill>
                   <a:srgbClr val="5B6577"/>
@@ -23146,6 +23493,7 @@
           <a:lstStyle xmlns:a="http://schemas.openxmlformats.org/drawingml/2006/main"/>
           <a:p xmlns:a="http://schemas.openxmlformats.org/drawingml/2006/main">
             <a:pPr algn="r">
+              <a:buNone/>
               <a:defRPr sz="1050" b="0">
                 <a:solidFill>
                   <a:srgbClr val="5B6577"/>
@@ -23204,6 +23552,7 @@
           <a:lstStyle xmlns:a="http://schemas.openxmlformats.org/drawingml/2006/main"/>
           <a:p xmlns:a="http://schemas.openxmlformats.org/drawingml/2006/main">
             <a:pPr algn="ctr">
+              <a:buNone/>
               <a:defRPr sz="1350" b="0">
                 <a:solidFill>
                   <a:srgbClr val="5B6577"/>
@@ -23229,7 +23578,7 @@
       </p:sp>
       <p:graphicFrame>
         <p:nvGraphicFramePr>
-          <p:cNvPr id="25" name="Chart"/>
+          <p:cNvPr id="27" name="Chart"/>
           <p:cNvGraphicFramePr/>
           <p:nvPr/>
         </p:nvGraphicFramePr>
@@ -23239,7 +23588,7 @@
         </p:xfrm>
         <a:graphic xmlns:a="http://schemas.openxmlformats.org/drawingml/2006/main">
           <a:graphicData uri="http://schemas.openxmlformats.org/drawingml/2006/chart">
-            <c:chart xmlns:r="http://schemas.openxmlformats.org/officeDocument/2006/relationships" xmlns:c="http://schemas.openxmlformats.org/drawingml/2006/chart" r:id="Rd6bbba2ba671460a"/>
+            <c:chart xmlns:r="http://schemas.openxmlformats.org/officeDocument/2006/relationships" xmlns:c="http://schemas.openxmlformats.org/drawingml/2006/chart" r:id="R647af27ce7c24f23"/>
           </a:graphicData>
         </a:graphic>
       </p:graphicFrame>
@@ -23311,6 +23660,7 @@
           <a:lstStyle xmlns:a="http://schemas.openxmlformats.org/drawingml/2006/main"/>
           <a:p xmlns:a="http://schemas.openxmlformats.org/drawingml/2006/main">
             <a:pPr algn="ctr">
+              <a:buNone/>
               <a:defRPr sz="1350" b="1">
                 <a:solidFill>
                   <a:srgbClr val="14B978"/>
@@ -23369,6 +23719,7 @@
           <a:lstStyle xmlns:a="http://schemas.openxmlformats.org/drawingml/2006/main"/>
           <a:p xmlns:a="http://schemas.openxmlformats.org/drawingml/2006/main">
             <a:pPr algn="ctr">
+              <a:buNone/>
               <a:defRPr sz="2175" b="1">
                 <a:solidFill>
                   <a:srgbClr val="FFFFFF"/>
@@ -23427,6 +23778,7 @@
           <a:lstStyle xmlns:a="http://schemas.openxmlformats.org/drawingml/2006/main"/>
           <a:p xmlns:a="http://schemas.openxmlformats.org/drawingml/2006/main">
             <a:pPr algn="ctr">
+              <a:buNone/>
               <a:defRPr sz="1275" b="0">
                 <a:solidFill>
                   <a:srgbClr val="DCE4F3"/>
@@ -23516,6 +23868,7 @@
           <a:lstStyle xmlns:a="http://schemas.openxmlformats.org/drawingml/2006/main"/>
           <a:p xmlns:a="http://schemas.openxmlformats.org/drawingml/2006/main">
             <a:pPr algn="ctr">
+              <a:buNone/>
               <a:defRPr sz="2175" b="1">
                 <a:solidFill>
                   <a:srgbClr val="FFFFFF"/>
@@ -23574,6 +23927,7 @@
           <a:lstStyle xmlns:a="http://schemas.openxmlformats.org/drawingml/2006/main"/>
           <a:p xmlns:a="http://schemas.openxmlformats.org/drawingml/2006/main">
             <a:pPr algn="ctr">
+              <a:buNone/>
               <a:defRPr sz="1275" b="0">
                 <a:solidFill>
                   <a:srgbClr val="DCE4F3"/>
@@ -23663,6 +24017,7 @@
           <a:lstStyle xmlns:a="http://schemas.openxmlformats.org/drawingml/2006/main"/>
           <a:p xmlns:a="http://schemas.openxmlformats.org/drawingml/2006/main">
             <a:pPr algn="ctr">
+              <a:buNone/>
               <a:defRPr sz="2175" b="1">
                 <a:solidFill>
                   <a:srgbClr val="FFFFFF"/>
@@ -23721,6 +24076,7 @@
           <a:lstStyle xmlns:a="http://schemas.openxmlformats.org/drawingml/2006/main"/>
           <a:p xmlns:a="http://schemas.openxmlformats.org/drawingml/2006/main">
             <a:pPr algn="ctr">
+              <a:buNone/>
               <a:defRPr sz="1275" b="0">
                 <a:solidFill>
                   <a:srgbClr val="DCE4F3"/>
@@ -23779,6 +24135,7 @@
           <a:lstStyle xmlns:a="http://schemas.openxmlformats.org/drawingml/2006/main"/>
           <a:p xmlns:a="http://schemas.openxmlformats.org/drawingml/2006/main">
             <a:pPr algn="ctr">
+              <a:buNone/>
               <a:defRPr sz="1500" b="1">
                 <a:solidFill>
                   <a:srgbClr val="233A70"/>

</xml_diff>